<commit_message>
Propagate validated MVT pivot into business plan and SoftBank deck
- Business plan: just-launched ICP timing, $1K money-back PoC lead offer, honest traction
- Deck: solution wedge + business model lead with money-back PoC; traction slide updated with family/payment-pending caveat in speaker notes
- Pitch package: pricing, traction Q&A, and integrity note aligned

Co-Authored-By: Claude Opus 4.8 <noreply@anthropic.com>
</commit_message>
<xml_diff>
--- a/docs/fundraising/pitch-deck-2026-06-11-softbank-necx.pptx
+++ b/docs/fundraising/pitch-deck-2026-06-11-softbank-necx.pptx
@@ -1289,7 +1289,7 @@
           <a:p>
             <a:r>
               <a:rPr lang="en-US" dirty="0"/>
-              <a:t>Why now: the CMS mandate makes EHR data accessible by right, the AI inflection makes the platform a seed-stage build, and the conviction cohort is growing while incumbents look the other way. Traction, exactly as it is: seven sessions with five physicians across two countries and five specialties, five verbal LOIs converting to written, willingness to pay quantified on record, working prototypes, and a named pipeline. Close on the surgeon's own words: 'If I spend a day in the ICU versus the clinic, I don't know where I am financially.' That is the company. Put doctors back in the driver's seat of their own financial future. [Stop. Take questions.]</a:t>
+              <a:t>Why now: the CMS mandate makes EHR data accessible by right, the AI inflection makes the platform a seed-stage build, and the conviction cohort is growing while incumbents look the other way. Traction, exactly as it is: seven sessions with five physicians across two countries and five specialties, willingness to pay quantified on record, working prototypes, and a named pipeline. On the first paid PoC — disclose proactively if asked: it is confirmed, but the subject is my brother (a post-launch ortho surgeon) and the payment is collected on delivery, which is in progress. I am deliberately not claiming arm's-length revenue yet; the first non-family, card-charged close is targeted inside 30 days (Tucci, Xin, or Cowan). Close on the surgeon's own words: 'If I spend a day in the ICU versus the clinic, I don't know where I am financially.' That is the company. Put doctors back in the driver's seat of their own financial future. [Stop. Take questions.]</a:t>
             </a:r>
             <a:endParaRPr lang="en-US" dirty="0"/>
           </a:p>
@@ -1553,7 +1553,7 @@
           <a:p>
             <a:r>
               <a:rPr lang="en-US" dirty="0"/>
-              <a:t>Two moves. The wedge is live today: a founder-guided transition program priced $750 to $20K — it earns revenue without a software build and every engagement writes the platform spec. The platform is what this round builds: an AI-native financial operating layer above the EHR — real-time P&amp;L, leak detection, credentialing intelligence — with zero migration. EHRs record what happened. We show where the practice is going.</a:t>
+              <a:t>Two moves. The wedge is live today. The validated tip-of-spear is a $1,000 money-back Proof-of-Concept: we find $20K you're not collecting, or it's free — then it ladders up to the done-for-you transition and the monthly subscription. It earns revenue without a software build, and every engagement writes the platform spec. The platform is what this round builds: an AI-native financial operating layer above the EHR — real-time P&amp;L, leak detection, credentialing intelligence — with zero migration. EHRs record what happened. We show where the practice is going.</a:t>
             </a:r>
             <a:endParaRPr lang="en-US" dirty="0"/>
           </a:p>
@@ -6330,7 +6330,7 @@
                 <a:ea typeface="Calibri" pitchFamily="34" charset="-122"/>
                 <a:cs typeface="Calibri" pitchFamily="34" charset="-120"/>
               </a:rPr>
-              <a:t>5 verbal LOIs converting to written; first paid close targeted inside 30 days</a:t>
+              <a:t>First paid PoC commitment confirmed; first arm's-length close targeted inside 30 days</a:t>
             </a:r>
             <a:endParaRPr lang="en-US" sz="1050" dirty="0"/>
           </a:p>
@@ -7891,7 +7891,7 @@
                 <a:ea typeface="Calibri" pitchFamily="34" charset="-122"/>
                 <a:cs typeface="Calibri" pitchFamily="34" charset="-120"/>
               </a:rPr>
-              <a:t>Founder-guided transition program for hospital-employed physicians going independent</a:t>
+              <a:t>Lead offer: $1,000 money-back PoC — “we find $20K you're not collecting, or it's free”</a:t>
             </a:r>
             <a:endParaRPr lang="en-US" sz="1200" dirty="0"/>
           </a:p>
@@ -7912,7 +7912,7 @@
                 <a:ea typeface="Calibri" pitchFamily="34" charset="-122"/>
                 <a:cs typeface="Calibri" pitchFamily="34" charset="-120"/>
               </a:rPr>
-              <a:t>$750 self-serve  →  $20K done-for-you</a:t>
+              <a:t>Upsell ladder to $20K done-for-you transition</a:t>
             </a:r>
             <a:endParaRPr lang="en-US" sz="1200" dirty="0"/>
           </a:p>
@@ -10935,8 +10935,165 @@
         </p:nvSpPr>
         <p:spPr>
           <a:xfrm>
-            <a:off x="457200" y="1280160"/>
-            <a:ext cx="5394960" cy="694944"/>
+            <a:off x="457200" y="1234440"/>
+            <a:ext cx="5394960" cy="548640"/>
+          </a:xfrm>
+          <a:prstGeom prst="rect">
+            <a:avLst/>
+          </a:prstGeom>
+          <a:solidFill>
+            <a:srgbClr val="1B2942"/>
+          </a:solidFill>
+          <a:ln/>
+        </p:spPr>
+      </p:sp>
+      <p:sp>
+        <p:nvSpPr>
+          <p:cNvPr id="5" name="Shape 3"/>
+          <p:cNvSpPr/>
+          <p:nvPr/>
+        </p:nvSpPr>
+        <p:spPr>
+          <a:xfrm>
+            <a:off x="457200" y="1234440"/>
+            <a:ext cx="64008" cy="548640"/>
+          </a:xfrm>
+          <a:prstGeom prst="rect">
+            <a:avLst/>
+          </a:prstGeom>
+          <a:solidFill>
+            <a:srgbClr val="2DD4BF"/>
+          </a:solidFill>
+          <a:ln/>
+        </p:spPr>
+      </p:sp>
+      <p:sp>
+        <p:nvSpPr>
+          <p:cNvPr id="6" name="Text 4"/>
+          <p:cNvSpPr/>
+          <p:nvPr/>
+        </p:nvSpPr>
+        <p:spPr>
+          <a:xfrm>
+            <a:off x="658368" y="1280160"/>
+            <a:ext cx="1783080" cy="457200"/>
+          </a:xfrm>
+          <a:prstGeom prst="rect">
+            <a:avLst/>
+          </a:prstGeom>
+          <a:noFill/>
+          <a:ln/>
+        </p:spPr>
+        <p:txBody>
+          <a:bodyPr wrap="square" lIns="0" tIns="0" rIns="0" bIns="0" rtlCol="0" anchor="ctr"/>
+          <a:lstStyle/>
+          <a:p>
+            <a:pPr indent="0" marL="0">
+              <a:buNone/>
+            </a:pPr>
+            <a:r>
+              <a:rPr lang="en-US" sz="1200" b="1" dirty="0">
+                <a:solidFill>
+                  <a:srgbClr val="2DD4BF"/>
+                </a:solidFill>
+                <a:latin typeface="Trebuchet MS" pitchFamily="34" charset="0"/>
+                <a:ea typeface="Trebuchet MS" pitchFamily="34" charset="-122"/>
+                <a:cs typeface="Trebuchet MS" pitchFamily="34" charset="-120"/>
+              </a:rPr>
+              <a:t>Money-back PoC</a:t>
+            </a:r>
+            <a:endParaRPr lang="en-US" sz="1200" dirty="0"/>
+          </a:p>
+        </p:txBody>
+      </p:sp>
+      <p:sp>
+        <p:nvSpPr>
+          <p:cNvPr id="7" name="Text 5"/>
+          <p:cNvSpPr/>
+          <p:nvPr/>
+        </p:nvSpPr>
+        <p:spPr>
+          <a:xfrm>
+            <a:off x="2468880" y="1280160"/>
+            <a:ext cx="1920240" cy="457200"/>
+          </a:xfrm>
+          <a:prstGeom prst="rect">
+            <a:avLst/>
+          </a:prstGeom>
+          <a:noFill/>
+          <a:ln/>
+        </p:spPr>
+        <p:txBody>
+          <a:bodyPr wrap="square" lIns="0" tIns="0" rIns="0" bIns="0" rtlCol="0" anchor="ctr"/>
+          <a:lstStyle/>
+          <a:p>
+            <a:pPr indent="0" marL="0">
+              <a:buNone/>
+            </a:pPr>
+            <a:r>
+              <a:rPr lang="en-US" sz="1050" b="1" dirty="0">
+                <a:solidFill>
+                  <a:srgbClr val="5EEAD4"/>
+                </a:solidFill>
+                <a:latin typeface="Calibri" pitchFamily="34" charset="0"/>
+                <a:ea typeface="Calibri" pitchFamily="34" charset="-122"/>
+                <a:cs typeface="Calibri" pitchFamily="34" charset="-120"/>
+              </a:rPr>
+              <a:t>$1,000 one-time</a:t>
+            </a:r>
+            <a:endParaRPr lang="en-US" sz="1050" dirty="0"/>
+          </a:p>
+        </p:txBody>
+      </p:sp>
+      <p:sp>
+        <p:nvSpPr>
+          <p:cNvPr id="8" name="Text 6"/>
+          <p:cNvSpPr/>
+          <p:nvPr/>
+        </p:nvSpPr>
+        <p:spPr>
+          <a:xfrm>
+            <a:off x="4434840" y="1280160"/>
+            <a:ext cx="1325880" cy="457200"/>
+          </a:xfrm>
+          <a:prstGeom prst="rect">
+            <a:avLst/>
+          </a:prstGeom>
+          <a:noFill/>
+          <a:ln/>
+        </p:spPr>
+        <p:txBody>
+          <a:bodyPr wrap="square" lIns="0" tIns="0" rIns="0" bIns="0" rtlCol="0" anchor="ctr"/>
+          <a:lstStyle/>
+          <a:p>
+            <a:pPr indent="0" marL="0">
+              <a:buNone/>
+            </a:pPr>
+            <a:r>
+              <a:rPr lang="en-US" sz="900" dirty="0">
+                <a:solidFill>
+                  <a:srgbClr val="8FA3BF"/>
+                </a:solidFill>
+                <a:latin typeface="Calibri" pitchFamily="34" charset="0"/>
+                <a:ea typeface="Calibri" pitchFamily="34" charset="-122"/>
+                <a:cs typeface="Calibri" pitchFamily="34" charset="-120"/>
+              </a:rPr>
+              <a:t>Lead offer: find $20K or it's free</a:t>
+            </a:r>
+            <a:endParaRPr lang="en-US" sz="900" dirty="0"/>
+          </a:p>
+        </p:txBody>
+      </p:sp>
+      <p:sp>
+        <p:nvSpPr>
+          <p:cNvPr id="9" name="Shape 7"/>
+          <p:cNvSpPr/>
+          <p:nvPr/>
+        </p:nvSpPr>
+        <p:spPr>
+          <a:xfrm>
+            <a:off x="457200" y="1874520"/>
+            <a:ext cx="5394960" cy="548640"/>
           </a:xfrm>
           <a:prstGeom prst="rect">
             <a:avLst/>
@@ -10949,30 +11106,30 @@
       </p:sp>
       <p:sp>
         <p:nvSpPr>
-          <p:cNvPr id="5" name="Text 3"/>
-          <p:cNvSpPr/>
-          <p:nvPr/>
-        </p:nvSpPr>
-        <p:spPr>
-          <a:xfrm>
-            <a:off x="658368" y="1362456"/>
-            <a:ext cx="1737360" cy="548640"/>
-          </a:xfrm>
-          <a:prstGeom prst="rect">
-            <a:avLst/>
-          </a:prstGeom>
-          <a:noFill/>
-          <a:ln/>
-        </p:spPr>
-        <p:txBody>
-          <a:bodyPr wrap="square" lIns="0" tIns="0" rIns="0" bIns="0" rtlCol="0" anchor="ctr"/>
-          <a:lstStyle/>
-          <a:p>
-            <a:pPr indent="0" marL="0">
-              <a:buNone/>
-            </a:pPr>
-            <a:r>
-              <a:rPr lang="en-US" sz="1250" b="1" dirty="0">
+          <p:cNvPr id="10" name="Text 8"/>
+          <p:cNvSpPr/>
+          <p:nvPr/>
+        </p:nvSpPr>
+        <p:spPr>
+          <a:xfrm>
+            <a:off x="658368" y="1920240"/>
+            <a:ext cx="1783080" cy="457200"/>
+          </a:xfrm>
+          <a:prstGeom prst="rect">
+            <a:avLst/>
+          </a:prstGeom>
+          <a:noFill/>
+          <a:ln/>
+        </p:spPr>
+        <p:txBody>
+          <a:bodyPr wrap="square" lIns="0" tIns="0" rIns="0" bIns="0" rtlCol="0" anchor="ctr"/>
+          <a:lstStyle/>
+          <a:p>
+            <a:pPr indent="0" marL="0">
+              <a:buNone/>
+            </a:pPr>
+            <a:r>
+              <a:rPr lang="en-US" sz="1200" b="1" dirty="0">
                 <a:solidFill>
                   <a:srgbClr val="FFFFFF"/>
                 </a:solidFill>
@@ -10982,36 +11139,36 @@
               </a:rPr>
               <a:t>Transition Kit</a:t>
             </a:r>
-            <a:endParaRPr lang="en-US" sz="1250" dirty="0"/>
-          </a:p>
-        </p:txBody>
-      </p:sp>
-      <p:sp>
-        <p:nvSpPr>
-          <p:cNvPr id="6" name="Text 4"/>
-          <p:cNvSpPr/>
-          <p:nvPr/>
-        </p:nvSpPr>
-        <p:spPr>
-          <a:xfrm>
-            <a:off x="2423160" y="1362456"/>
-            <a:ext cx="1874520" cy="548640"/>
-          </a:xfrm>
-          <a:prstGeom prst="rect">
-            <a:avLst/>
-          </a:prstGeom>
-          <a:noFill/>
-          <a:ln/>
-        </p:spPr>
-        <p:txBody>
-          <a:bodyPr wrap="square" lIns="0" tIns="0" rIns="0" bIns="0" rtlCol="0" anchor="ctr"/>
-          <a:lstStyle/>
-          <a:p>
-            <a:pPr indent="0" marL="0">
-              <a:buNone/>
-            </a:pPr>
-            <a:r>
-              <a:rPr lang="en-US" sz="1100" b="1" dirty="0">
+            <a:endParaRPr lang="en-US" sz="1200" dirty="0"/>
+          </a:p>
+        </p:txBody>
+      </p:sp>
+      <p:sp>
+        <p:nvSpPr>
+          <p:cNvPr id="11" name="Text 9"/>
+          <p:cNvSpPr/>
+          <p:nvPr/>
+        </p:nvSpPr>
+        <p:spPr>
+          <a:xfrm>
+            <a:off x="2468880" y="1920240"/>
+            <a:ext cx="1920240" cy="457200"/>
+          </a:xfrm>
+          <a:prstGeom prst="rect">
+            <a:avLst/>
+          </a:prstGeom>
+          <a:noFill/>
+          <a:ln/>
+        </p:spPr>
+        <p:txBody>
+          <a:bodyPr wrap="square" lIns="0" tIns="0" rIns="0" bIns="0" rtlCol="0" anchor="ctr"/>
+          <a:lstStyle/>
+          <a:p>
+            <a:pPr indent="0" marL="0">
+              <a:buNone/>
+            </a:pPr>
+            <a:r>
+              <a:rPr lang="en-US" sz="1050" b="1" dirty="0">
                 <a:solidFill>
                   <a:srgbClr val="5EEAD4"/>
                 </a:solidFill>
@@ -11021,36 +11178,36 @@
               </a:rPr>
               <a:t>$750–$1,000 one-time</a:t>
             </a:r>
-            <a:endParaRPr lang="en-US" sz="1100" dirty="0"/>
-          </a:p>
-        </p:txBody>
-      </p:sp>
-      <p:sp>
-        <p:nvSpPr>
-          <p:cNvPr id="7" name="Text 5"/>
-          <p:cNvSpPr/>
-          <p:nvPr/>
-        </p:nvSpPr>
-        <p:spPr>
-          <a:xfrm>
-            <a:off x="4343400" y="1362456"/>
-            <a:ext cx="1417320" cy="548640"/>
-          </a:xfrm>
-          <a:prstGeom prst="rect">
-            <a:avLst/>
-          </a:prstGeom>
-          <a:noFill/>
-          <a:ln/>
-        </p:spPr>
-        <p:txBody>
-          <a:bodyPr wrap="square" lIns="0" tIns="0" rIns="0" bIns="0" rtlCol="0" anchor="ctr"/>
-          <a:lstStyle/>
-          <a:p>
-            <a:pPr indent="0" marL="0">
-              <a:buNone/>
-            </a:pPr>
-            <a:r>
-              <a:rPr lang="en-US" sz="950" dirty="0">
+            <a:endParaRPr lang="en-US" sz="1050" dirty="0"/>
+          </a:p>
+        </p:txBody>
+      </p:sp>
+      <p:sp>
+        <p:nvSpPr>
+          <p:cNvPr id="12" name="Text 10"/>
+          <p:cNvSpPr/>
+          <p:nvPr/>
+        </p:nvSpPr>
+        <p:spPr>
+          <a:xfrm>
+            <a:off x="4434840" y="1920240"/>
+            <a:ext cx="1325880" cy="457200"/>
+          </a:xfrm>
+          <a:prstGeom prst="rect">
+            <a:avLst/>
+          </a:prstGeom>
+          <a:noFill/>
+          <a:ln/>
+        </p:spPr>
+        <p:txBody>
+          <a:bodyPr wrap="square" lIns="0" tIns="0" rIns="0" bIns="0" rtlCol="0" anchor="ctr"/>
+          <a:lstStyle/>
+          <a:p>
+            <a:pPr indent="0" marL="0">
+              <a:buNone/>
+            </a:pPr>
+            <a:r>
+              <a:rPr lang="en-US" sz="900" dirty="0">
                 <a:solidFill>
                   <a:srgbClr val="8FA3BF"/>
                 </a:solidFill>
@@ -11060,20 +11217,20 @@
               </a:rPr>
               <a:t>Self-serve digital launch kit</a:t>
             </a:r>
-            <a:endParaRPr lang="en-US" sz="950" dirty="0"/>
-          </a:p>
-        </p:txBody>
-      </p:sp>
-      <p:sp>
-        <p:nvSpPr>
-          <p:cNvPr id="8" name="Shape 6"/>
-          <p:cNvSpPr/>
-          <p:nvPr/>
-        </p:nvSpPr>
-        <p:spPr>
-          <a:xfrm>
-            <a:off x="457200" y="2084832"/>
-            <a:ext cx="5394960" cy="694944"/>
+            <a:endParaRPr lang="en-US" sz="900" dirty="0"/>
+          </a:p>
+        </p:txBody>
+      </p:sp>
+      <p:sp>
+        <p:nvSpPr>
+          <p:cNvPr id="13" name="Shape 11"/>
+          <p:cNvSpPr/>
+          <p:nvPr/>
+        </p:nvSpPr>
+        <p:spPr>
+          <a:xfrm>
+            <a:off x="457200" y="2514600"/>
+            <a:ext cx="5394960" cy="548640"/>
           </a:xfrm>
           <a:prstGeom prst="rect">
             <a:avLst/>
@@ -11086,30 +11243,30 @@
       </p:sp>
       <p:sp>
         <p:nvSpPr>
-          <p:cNvPr id="9" name="Text 7"/>
-          <p:cNvSpPr/>
-          <p:nvPr/>
-        </p:nvSpPr>
-        <p:spPr>
-          <a:xfrm>
-            <a:off x="658368" y="2167128"/>
-            <a:ext cx="1737360" cy="548640"/>
-          </a:xfrm>
-          <a:prstGeom prst="rect">
-            <a:avLst/>
-          </a:prstGeom>
-          <a:noFill/>
-          <a:ln/>
-        </p:spPr>
-        <p:txBody>
-          <a:bodyPr wrap="square" lIns="0" tIns="0" rIns="0" bIns="0" rtlCol="0" anchor="ctr"/>
-          <a:lstStyle/>
-          <a:p>
-            <a:pPr indent="0" marL="0">
-              <a:buNone/>
-            </a:pPr>
-            <a:r>
-              <a:rPr lang="en-US" sz="1250" b="1" dirty="0">
+          <p:cNvPr id="14" name="Text 12"/>
+          <p:cNvSpPr/>
+          <p:nvPr/>
+        </p:nvSpPr>
+        <p:spPr>
+          <a:xfrm>
+            <a:off x="658368" y="2560320"/>
+            <a:ext cx="1783080" cy="457200"/>
+          </a:xfrm>
+          <a:prstGeom prst="rect">
+            <a:avLst/>
+          </a:prstGeom>
+          <a:noFill/>
+          <a:ln/>
+        </p:spPr>
+        <p:txBody>
+          <a:bodyPr wrap="square" lIns="0" tIns="0" rIns="0" bIns="0" rtlCol="0" anchor="ctr"/>
+          <a:lstStyle/>
+          <a:p>
+            <a:pPr indent="0" marL="0">
+              <a:buNone/>
+            </a:pPr>
+            <a:r>
+              <a:rPr lang="en-US" sz="1200" b="1" dirty="0">
                 <a:solidFill>
                   <a:srgbClr val="FFFFFF"/>
                 </a:solidFill>
@@ -11119,36 +11276,36 @@
               </a:rPr>
               <a:t>Transition Program</a:t>
             </a:r>
-            <a:endParaRPr lang="en-US" sz="1250" dirty="0"/>
-          </a:p>
-        </p:txBody>
-      </p:sp>
-      <p:sp>
-        <p:nvSpPr>
-          <p:cNvPr id="10" name="Text 8"/>
-          <p:cNvSpPr/>
-          <p:nvPr/>
-        </p:nvSpPr>
-        <p:spPr>
-          <a:xfrm>
-            <a:off x="2423160" y="2167128"/>
-            <a:ext cx="1874520" cy="548640"/>
-          </a:xfrm>
-          <a:prstGeom prst="rect">
-            <a:avLst/>
-          </a:prstGeom>
-          <a:noFill/>
-          <a:ln/>
-        </p:spPr>
-        <p:txBody>
-          <a:bodyPr wrap="square" lIns="0" tIns="0" rIns="0" bIns="0" rtlCol="0" anchor="ctr"/>
-          <a:lstStyle/>
-          <a:p>
-            <a:pPr indent="0" marL="0">
-              <a:buNone/>
-            </a:pPr>
-            <a:r>
-              <a:rPr lang="en-US" sz="1100" b="1" dirty="0">
+            <a:endParaRPr lang="en-US" sz="1200" dirty="0"/>
+          </a:p>
+        </p:txBody>
+      </p:sp>
+      <p:sp>
+        <p:nvSpPr>
+          <p:cNvPr id="15" name="Text 13"/>
+          <p:cNvSpPr/>
+          <p:nvPr/>
+        </p:nvSpPr>
+        <p:spPr>
+          <a:xfrm>
+            <a:off x="2468880" y="2560320"/>
+            <a:ext cx="1920240" cy="457200"/>
+          </a:xfrm>
+          <a:prstGeom prst="rect">
+            <a:avLst/>
+          </a:prstGeom>
+          <a:noFill/>
+          <a:ln/>
+        </p:spPr>
+        <p:txBody>
+          <a:bodyPr wrap="square" lIns="0" tIns="0" rIns="0" bIns="0" rtlCol="0" anchor="ctr"/>
+          <a:lstStyle/>
+          <a:p>
+            <a:pPr indent="0" marL="0">
+              <a:buNone/>
+            </a:pPr>
+            <a:r>
+              <a:rPr lang="en-US" sz="1050" b="1" dirty="0">
                 <a:solidFill>
                   <a:srgbClr val="5EEAD4"/>
                 </a:solidFill>
@@ -11156,38 +11313,38 @@
                 <a:ea typeface="Calibri" pitchFamily="34" charset="-122"/>
                 <a:cs typeface="Calibri" pitchFamily="34" charset="-120"/>
               </a:rPr>
-              <a:t>$3,500–$5,000  +  $500–799/mo</a:t>
-            </a:r>
-            <a:endParaRPr lang="en-US" sz="1100" dirty="0"/>
-          </a:p>
-        </p:txBody>
-      </p:sp>
-      <p:sp>
-        <p:nvSpPr>
-          <p:cNvPr id="11" name="Text 9"/>
-          <p:cNvSpPr/>
-          <p:nvPr/>
-        </p:nvSpPr>
-        <p:spPr>
-          <a:xfrm>
-            <a:off x="4343400" y="2167128"/>
-            <a:ext cx="1417320" cy="548640"/>
-          </a:xfrm>
-          <a:prstGeom prst="rect">
-            <a:avLst/>
-          </a:prstGeom>
-          <a:noFill/>
-          <a:ln/>
-        </p:spPr>
-        <p:txBody>
-          <a:bodyPr wrap="square" lIns="0" tIns="0" rIns="0" bIns="0" rtlCol="0" anchor="ctr"/>
-          <a:lstStyle/>
-          <a:p>
-            <a:pPr indent="0" marL="0">
-              <a:buNone/>
-            </a:pPr>
-            <a:r>
-              <a:rPr lang="en-US" sz="950" dirty="0">
+              <a:t>$3,500–$5,000 + $500–799/mo</a:t>
+            </a:r>
+            <a:endParaRPr lang="en-US" sz="1050" dirty="0"/>
+          </a:p>
+        </p:txBody>
+      </p:sp>
+      <p:sp>
+        <p:nvSpPr>
+          <p:cNvPr id="16" name="Text 14"/>
+          <p:cNvSpPr/>
+          <p:nvPr/>
+        </p:nvSpPr>
+        <p:spPr>
+          <a:xfrm>
+            <a:off x="4434840" y="2560320"/>
+            <a:ext cx="1325880" cy="457200"/>
+          </a:xfrm>
+          <a:prstGeom prst="rect">
+            <a:avLst/>
+          </a:prstGeom>
+          <a:noFill/>
+          <a:ln/>
+        </p:spPr>
+        <p:txBody>
+          <a:bodyPr wrap="square" lIns="0" tIns="0" rIns="0" bIns="0" rtlCol="0" anchor="ctr"/>
+          <a:lstStyle/>
+          <a:p>
+            <a:pPr indent="0" marL="0">
+              <a:buNone/>
+            </a:pPr>
+            <a:r>
+              <a:rPr lang="en-US" sz="900" dirty="0">
                 <a:solidFill>
                   <a:srgbClr val="8FA3BF"/>
                 </a:solidFill>
@@ -11197,20 +11354,20 @@
               </a:rPr>
               <a:t>Founder-guided, 12 weeks</a:t>
             </a:r>
-            <a:endParaRPr lang="en-US" sz="950" dirty="0"/>
-          </a:p>
-        </p:txBody>
-      </p:sp>
-      <p:sp>
-        <p:nvSpPr>
-          <p:cNvPr id="12" name="Shape 10"/>
-          <p:cNvSpPr/>
-          <p:nvPr/>
-        </p:nvSpPr>
-        <p:spPr>
-          <a:xfrm>
-            <a:off x="457200" y="2889504"/>
-            <a:ext cx="5394960" cy="694944"/>
+            <a:endParaRPr lang="en-US" sz="900" dirty="0"/>
+          </a:p>
+        </p:txBody>
+      </p:sp>
+      <p:sp>
+        <p:nvSpPr>
+          <p:cNvPr id="17" name="Shape 15"/>
+          <p:cNvSpPr/>
+          <p:nvPr/>
+        </p:nvSpPr>
+        <p:spPr>
+          <a:xfrm>
+            <a:off x="457200" y="3154680"/>
+            <a:ext cx="5394960" cy="548640"/>
           </a:xfrm>
           <a:prstGeom prst="rect">
             <a:avLst/>
@@ -11223,30 +11380,30 @@
       </p:sp>
       <p:sp>
         <p:nvSpPr>
-          <p:cNvPr id="13" name="Text 11"/>
-          <p:cNvSpPr/>
-          <p:nvPr/>
-        </p:nvSpPr>
-        <p:spPr>
-          <a:xfrm>
-            <a:off x="658368" y="2971800"/>
-            <a:ext cx="1737360" cy="548640"/>
-          </a:xfrm>
-          <a:prstGeom prst="rect">
-            <a:avLst/>
-          </a:prstGeom>
-          <a:noFill/>
-          <a:ln/>
-        </p:spPr>
-        <p:txBody>
-          <a:bodyPr wrap="square" lIns="0" tIns="0" rIns="0" bIns="0" rtlCol="0" anchor="ctr"/>
-          <a:lstStyle/>
-          <a:p>
-            <a:pPr indent="0" marL="0">
-              <a:buNone/>
-            </a:pPr>
-            <a:r>
-              <a:rPr lang="en-US" sz="1250" b="1" dirty="0">
+          <p:cNvPr id="18" name="Text 16"/>
+          <p:cNvSpPr/>
+          <p:nvPr/>
+        </p:nvSpPr>
+        <p:spPr>
+          <a:xfrm>
+            <a:off x="658368" y="3200400"/>
+            <a:ext cx="1783080" cy="457200"/>
+          </a:xfrm>
+          <a:prstGeom prst="rect">
+            <a:avLst/>
+          </a:prstGeom>
+          <a:noFill/>
+          <a:ln/>
+        </p:spPr>
+        <p:txBody>
+          <a:bodyPr wrap="square" lIns="0" tIns="0" rIns="0" bIns="0" rtlCol="0" anchor="ctr"/>
+          <a:lstStyle/>
+          <a:p>
+            <a:pPr indent="0" marL="0">
+              <a:buNone/>
+            </a:pPr>
+            <a:r>
+              <a:rPr lang="en-US" sz="1200" b="1" dirty="0">
                 <a:solidFill>
                   <a:srgbClr val="FFFFFF"/>
                 </a:solidFill>
@@ -11256,36 +11413,36 @@
               </a:rPr>
               <a:t>Full Transition</a:t>
             </a:r>
-            <a:endParaRPr lang="en-US" sz="1250" dirty="0"/>
-          </a:p>
-        </p:txBody>
-      </p:sp>
-      <p:sp>
-        <p:nvSpPr>
-          <p:cNvPr id="14" name="Text 12"/>
-          <p:cNvSpPr/>
-          <p:nvPr/>
-        </p:nvSpPr>
-        <p:spPr>
-          <a:xfrm>
-            <a:off x="2423160" y="2971800"/>
-            <a:ext cx="1874520" cy="548640"/>
-          </a:xfrm>
-          <a:prstGeom prst="rect">
-            <a:avLst/>
-          </a:prstGeom>
-          <a:noFill/>
-          <a:ln/>
-        </p:spPr>
-        <p:txBody>
-          <a:bodyPr wrap="square" lIns="0" tIns="0" rIns="0" bIns="0" rtlCol="0" anchor="ctr"/>
-          <a:lstStyle/>
-          <a:p>
-            <a:pPr indent="0" marL="0">
-              <a:buNone/>
-            </a:pPr>
-            <a:r>
-              <a:rPr lang="en-US" sz="1100" b="1" dirty="0">
+            <a:endParaRPr lang="en-US" sz="1200" dirty="0"/>
+          </a:p>
+        </p:txBody>
+      </p:sp>
+      <p:sp>
+        <p:nvSpPr>
+          <p:cNvPr id="19" name="Text 17"/>
+          <p:cNvSpPr/>
+          <p:nvPr/>
+        </p:nvSpPr>
+        <p:spPr>
+          <a:xfrm>
+            <a:off x="2468880" y="3200400"/>
+            <a:ext cx="1920240" cy="457200"/>
+          </a:xfrm>
+          <a:prstGeom prst="rect">
+            <a:avLst/>
+          </a:prstGeom>
+          <a:noFill/>
+          <a:ln/>
+        </p:spPr>
+        <p:txBody>
+          <a:bodyPr wrap="square" lIns="0" tIns="0" rIns="0" bIns="0" rtlCol="0" anchor="ctr"/>
+          <a:lstStyle/>
+          <a:p>
+            <a:pPr indent="0" marL="0">
+              <a:buNone/>
+            </a:pPr>
+            <a:r>
+              <a:rPr lang="en-US" sz="1050" b="1" dirty="0">
                 <a:solidFill>
                   <a:srgbClr val="5EEAD4"/>
                 </a:solidFill>
@@ -11293,38 +11450,38 @@
                 <a:ea typeface="Calibri" pitchFamily="34" charset="-122"/>
                 <a:cs typeface="Calibri" pitchFamily="34" charset="-120"/>
               </a:rPr>
-              <a:t>$8,000–$20,000  +  $500–799/mo</a:t>
-            </a:r>
-            <a:endParaRPr lang="en-US" sz="1100" dirty="0"/>
-          </a:p>
-        </p:txBody>
-      </p:sp>
-      <p:sp>
-        <p:nvSpPr>
-          <p:cNvPr id="15" name="Text 13"/>
-          <p:cNvSpPr/>
-          <p:nvPr/>
-        </p:nvSpPr>
-        <p:spPr>
-          <a:xfrm>
-            <a:off x="4343400" y="2971800"/>
-            <a:ext cx="1417320" cy="548640"/>
-          </a:xfrm>
-          <a:prstGeom prst="rect">
-            <a:avLst/>
-          </a:prstGeom>
-          <a:noFill/>
-          <a:ln/>
-        </p:spPr>
-        <p:txBody>
-          <a:bodyPr wrap="square" lIns="0" tIns="0" rIns="0" bIns="0" rtlCol="0" anchor="ctr"/>
-          <a:lstStyle/>
-          <a:p>
-            <a:pPr indent="0" marL="0">
-              <a:buNone/>
-            </a:pPr>
-            <a:r>
-              <a:rPr lang="en-US" sz="950" dirty="0">
+              <a:t>$8,000–$20,000 + $500–799/mo</a:t>
+            </a:r>
+            <a:endParaRPr lang="en-US" sz="1050" dirty="0"/>
+          </a:p>
+        </p:txBody>
+      </p:sp>
+      <p:sp>
+        <p:nvSpPr>
+          <p:cNvPr id="20" name="Text 18"/>
+          <p:cNvSpPr/>
+          <p:nvPr/>
+        </p:nvSpPr>
+        <p:spPr>
+          <a:xfrm>
+            <a:off x="4434840" y="3200400"/>
+            <a:ext cx="1325880" cy="457200"/>
+          </a:xfrm>
+          <a:prstGeom prst="rect">
+            <a:avLst/>
+          </a:prstGeom>
+          <a:noFill/>
+          <a:ln/>
+        </p:spPr>
+        <p:txBody>
+          <a:bodyPr wrap="square" lIns="0" tIns="0" rIns="0" bIns="0" rtlCol="0" anchor="ctr"/>
+          <a:lstStyle/>
+          <a:p>
+            <a:pPr indent="0" marL="0">
+              <a:buNone/>
+            </a:pPr>
+            <a:r>
+              <a:rPr lang="en-US" sz="900" dirty="0">
                 <a:solidFill>
                   <a:srgbClr val="8FA3BF"/>
                 </a:solidFill>
@@ -11332,22 +11489,159 @@
                 <a:ea typeface="Calibri" pitchFamily="34" charset="-122"/>
                 <a:cs typeface="Calibri" pitchFamily="34" charset="-120"/>
               </a:rPr>
-              <a:t>Done-for-you, high-earner specialists</a:t>
-            </a:r>
-            <a:endParaRPr lang="en-US" sz="950" dirty="0"/>
-          </a:p>
-        </p:txBody>
-      </p:sp>
-      <p:sp>
-        <p:nvSpPr>
-          <p:cNvPr id="16" name="Shape 14"/>
-          <p:cNvSpPr/>
-          <p:nvPr/>
-        </p:nvSpPr>
-        <p:spPr>
-          <a:xfrm>
-            <a:off x="457200" y="3694176"/>
-            <a:ext cx="5394960" cy="694944"/>
+              <a:t>Done-for-you specialists</a:t>
+            </a:r>
+            <a:endParaRPr lang="en-US" sz="900" dirty="0"/>
+          </a:p>
+        </p:txBody>
+      </p:sp>
+      <p:sp>
+        <p:nvSpPr>
+          <p:cNvPr id="21" name="Shape 19"/>
+          <p:cNvSpPr/>
+          <p:nvPr/>
+        </p:nvSpPr>
+        <p:spPr>
+          <a:xfrm>
+            <a:off x="457200" y="3794760"/>
+            <a:ext cx="5394960" cy="548640"/>
+          </a:xfrm>
+          <a:prstGeom prst="rect">
+            <a:avLst/>
+          </a:prstGeom>
+          <a:solidFill>
+            <a:srgbClr val="16213A"/>
+          </a:solidFill>
+          <a:ln/>
+        </p:spPr>
+      </p:sp>
+      <p:sp>
+        <p:nvSpPr>
+          <p:cNvPr id="22" name="Text 20"/>
+          <p:cNvSpPr/>
+          <p:nvPr/>
+        </p:nvSpPr>
+        <p:spPr>
+          <a:xfrm>
+            <a:off x="658368" y="3840480"/>
+            <a:ext cx="1783080" cy="457200"/>
+          </a:xfrm>
+          <a:prstGeom prst="rect">
+            <a:avLst/>
+          </a:prstGeom>
+          <a:noFill/>
+          <a:ln/>
+        </p:spPr>
+        <p:txBody>
+          <a:bodyPr wrap="square" lIns="0" tIns="0" rIns="0" bIns="0" rtlCol="0" anchor="ctr"/>
+          <a:lstStyle/>
+          <a:p>
+            <a:pPr indent="0" marL="0">
+              <a:buNone/>
+            </a:pPr>
+            <a:r>
+              <a:rPr lang="en-US" sz="1200" b="1" dirty="0">
+                <a:solidFill>
+                  <a:srgbClr val="FFFFFF"/>
+                </a:solidFill>
+                <a:latin typeface="Trebuchet MS" pitchFamily="34" charset="0"/>
+                <a:ea typeface="Trebuchet MS" pitchFamily="34" charset="-122"/>
+                <a:cs typeface="Trebuchet MS" pitchFamily="34" charset="-120"/>
+              </a:rPr>
+              <a:t>Platform OS</a:t>
+            </a:r>
+            <a:endParaRPr lang="en-US" sz="1200" dirty="0"/>
+          </a:p>
+        </p:txBody>
+      </p:sp>
+      <p:sp>
+        <p:nvSpPr>
+          <p:cNvPr id="23" name="Text 21"/>
+          <p:cNvSpPr/>
+          <p:nvPr/>
+        </p:nvSpPr>
+        <p:spPr>
+          <a:xfrm>
+            <a:off x="2468880" y="3840480"/>
+            <a:ext cx="1920240" cy="457200"/>
+          </a:xfrm>
+          <a:prstGeom prst="rect">
+            <a:avLst/>
+          </a:prstGeom>
+          <a:noFill/>
+          <a:ln/>
+        </p:spPr>
+        <p:txBody>
+          <a:bodyPr wrap="square" lIns="0" tIns="0" rIns="0" bIns="0" rtlCol="0" anchor="ctr"/>
+          <a:lstStyle/>
+          <a:p>
+            <a:pPr indent="0" marL="0">
+              <a:buNone/>
+            </a:pPr>
+            <a:r>
+              <a:rPr lang="en-US" sz="1050" b="1" dirty="0">
+                <a:solidFill>
+                  <a:srgbClr val="5EEAD4"/>
+                </a:solidFill>
+                <a:latin typeface="Calibri" pitchFamily="34" charset="0"/>
+                <a:ea typeface="Calibri" pitchFamily="34" charset="-122"/>
+                <a:cs typeface="Calibri" pitchFamily="34" charset="-120"/>
+              </a:rPr>
+              <a:t>$500–799/mo recurring</a:t>
+            </a:r>
+            <a:endParaRPr lang="en-US" sz="1050" dirty="0"/>
+          </a:p>
+        </p:txBody>
+      </p:sp>
+      <p:sp>
+        <p:nvSpPr>
+          <p:cNvPr id="24" name="Text 22"/>
+          <p:cNvSpPr/>
+          <p:nvPr/>
+        </p:nvSpPr>
+        <p:spPr>
+          <a:xfrm>
+            <a:off x="4434840" y="3840480"/>
+            <a:ext cx="1325880" cy="457200"/>
+          </a:xfrm>
+          <a:prstGeom prst="rect">
+            <a:avLst/>
+          </a:prstGeom>
+          <a:noFill/>
+          <a:ln/>
+        </p:spPr>
+        <p:txBody>
+          <a:bodyPr wrap="square" lIns="0" tIns="0" rIns="0" bIns="0" rtlCol="0" anchor="ctr"/>
+          <a:lstStyle/>
+          <a:p>
+            <a:pPr indent="0" marL="0">
+              <a:buNone/>
+            </a:pPr>
+            <a:r>
+              <a:rPr lang="en-US" sz="900" dirty="0">
+                <a:solidFill>
+                  <a:srgbClr val="8FA3BF"/>
+                </a:solidFill>
+                <a:latin typeface="Calibri" pitchFamily="34" charset="0"/>
+                <a:ea typeface="Calibri" pitchFamily="34" charset="-122"/>
+                <a:cs typeface="Calibri" pitchFamily="34" charset="-120"/>
+              </a:rPr>
+              <a:t>Every clinic graduates here</a:t>
+            </a:r>
+            <a:endParaRPr lang="en-US" sz="900" dirty="0"/>
+          </a:p>
+        </p:txBody>
+      </p:sp>
+      <p:sp>
+        <p:nvSpPr>
+          <p:cNvPr id="25" name="Shape 23"/>
+          <p:cNvSpPr/>
+          <p:nvPr/>
+        </p:nvSpPr>
+        <p:spPr>
+          <a:xfrm>
+            <a:off x="6080760" y="1280160"/>
+            <a:ext cx="2606040" cy="3108960"/>
           </a:xfrm>
           <a:prstGeom prst="rect">
             <a:avLst/>
@@ -11360,30 +11654,30 @@
       </p:sp>
       <p:sp>
         <p:nvSpPr>
-          <p:cNvPr id="17" name="Text 15"/>
-          <p:cNvSpPr/>
-          <p:nvPr/>
-        </p:nvSpPr>
-        <p:spPr>
-          <a:xfrm>
-            <a:off x="658368" y="3776472"/>
-            <a:ext cx="1737360" cy="548640"/>
-          </a:xfrm>
-          <a:prstGeom prst="rect">
-            <a:avLst/>
-          </a:prstGeom>
-          <a:noFill/>
-          <a:ln/>
-        </p:spPr>
-        <p:txBody>
-          <a:bodyPr wrap="square" lIns="0" tIns="0" rIns="0" bIns="0" rtlCol="0" anchor="ctr"/>
-          <a:lstStyle/>
-          <a:p>
-            <a:pPr indent="0" marL="0">
-              <a:buNone/>
-            </a:pPr>
-            <a:r>
-              <a:rPr lang="en-US" sz="1250" b="1" dirty="0">
+          <p:cNvPr id="26" name="Text 24"/>
+          <p:cNvSpPr/>
+          <p:nvPr/>
+        </p:nvSpPr>
+        <p:spPr>
+          <a:xfrm>
+            <a:off x="6281928" y="1463040"/>
+            <a:ext cx="2194560" cy="274320"/>
+          </a:xfrm>
+          <a:prstGeom prst="rect">
+            <a:avLst/>
+          </a:prstGeom>
+          <a:noFill/>
+          <a:ln/>
+        </p:spPr>
+        <p:txBody>
+          <a:bodyPr wrap="square" lIns="0" tIns="0" rIns="0" bIns="0" rtlCol="0" anchor="ctr"/>
+          <a:lstStyle/>
+          <a:p>
+            <a:pPr indent="0" marL="0">
+              <a:buNone/>
+            </a:pPr>
+            <a:r>
+              <a:rPr lang="en-US" sz="1050" b="1" spc="200" kern="0" dirty="0">
                 <a:solidFill>
                   <a:srgbClr val="2DD4BF"/>
                 </a:solidFill>
@@ -11391,143 +11685,6 @@
                 <a:ea typeface="Trebuchet MS" pitchFamily="34" charset="-122"/>
                 <a:cs typeface="Trebuchet MS" pitchFamily="34" charset="-120"/>
               </a:rPr>
-              <a:t>Platform OS</a:t>
-            </a:r>
-            <a:endParaRPr lang="en-US" sz="1250" dirty="0"/>
-          </a:p>
-        </p:txBody>
-      </p:sp>
-      <p:sp>
-        <p:nvSpPr>
-          <p:cNvPr id="18" name="Text 16"/>
-          <p:cNvSpPr/>
-          <p:nvPr/>
-        </p:nvSpPr>
-        <p:spPr>
-          <a:xfrm>
-            <a:off x="2423160" y="3776472"/>
-            <a:ext cx="1874520" cy="548640"/>
-          </a:xfrm>
-          <a:prstGeom prst="rect">
-            <a:avLst/>
-          </a:prstGeom>
-          <a:noFill/>
-          <a:ln/>
-        </p:spPr>
-        <p:txBody>
-          <a:bodyPr wrap="square" lIns="0" tIns="0" rIns="0" bIns="0" rtlCol="0" anchor="ctr"/>
-          <a:lstStyle/>
-          <a:p>
-            <a:pPr indent="0" marL="0">
-              <a:buNone/>
-            </a:pPr>
-            <a:r>
-              <a:rPr lang="en-US" sz="1100" b="1" dirty="0">
-                <a:solidFill>
-                  <a:srgbClr val="5EEAD4"/>
-                </a:solidFill>
-                <a:latin typeface="Calibri" pitchFamily="34" charset="0"/>
-                <a:ea typeface="Calibri" pitchFamily="34" charset="-122"/>
-                <a:cs typeface="Calibri" pitchFamily="34" charset="-120"/>
-              </a:rPr>
-              <a:t>$500–799/mo recurring</a:t>
-            </a:r>
-            <a:endParaRPr lang="en-US" sz="1100" dirty="0"/>
-          </a:p>
-        </p:txBody>
-      </p:sp>
-      <p:sp>
-        <p:nvSpPr>
-          <p:cNvPr id="19" name="Text 17"/>
-          <p:cNvSpPr/>
-          <p:nvPr/>
-        </p:nvSpPr>
-        <p:spPr>
-          <a:xfrm>
-            <a:off x="4343400" y="3776472"/>
-            <a:ext cx="1417320" cy="548640"/>
-          </a:xfrm>
-          <a:prstGeom prst="rect">
-            <a:avLst/>
-          </a:prstGeom>
-          <a:noFill/>
-          <a:ln/>
-        </p:spPr>
-        <p:txBody>
-          <a:bodyPr wrap="square" lIns="0" tIns="0" rIns="0" bIns="0" rtlCol="0" anchor="ctr"/>
-          <a:lstStyle/>
-          <a:p>
-            <a:pPr indent="0" marL="0">
-              <a:buNone/>
-            </a:pPr>
-            <a:r>
-              <a:rPr lang="en-US" sz="950" dirty="0">
-                <a:solidFill>
-                  <a:srgbClr val="8FA3BF"/>
-                </a:solidFill>
-                <a:latin typeface="Calibri" pitchFamily="34" charset="0"/>
-                <a:ea typeface="Calibri" pitchFamily="34" charset="-122"/>
-                <a:cs typeface="Calibri" pitchFamily="34" charset="-120"/>
-              </a:rPr>
-              <a:t>Post-launch financial layer — every clinic graduates here</a:t>
-            </a:r>
-            <a:endParaRPr lang="en-US" sz="950" dirty="0"/>
-          </a:p>
-        </p:txBody>
-      </p:sp>
-      <p:sp>
-        <p:nvSpPr>
-          <p:cNvPr id="20" name="Shape 18"/>
-          <p:cNvSpPr/>
-          <p:nvPr/>
-        </p:nvSpPr>
-        <p:spPr>
-          <a:xfrm>
-            <a:off x="6080760" y="1280160"/>
-            <a:ext cx="2606040" cy="3108960"/>
-          </a:xfrm>
-          <a:prstGeom prst="rect">
-            <a:avLst/>
-          </a:prstGeom>
-          <a:solidFill>
-            <a:srgbClr val="1B2942"/>
-          </a:solidFill>
-          <a:ln/>
-        </p:spPr>
-      </p:sp>
-      <p:sp>
-        <p:nvSpPr>
-          <p:cNvPr id="21" name="Text 19"/>
-          <p:cNvSpPr/>
-          <p:nvPr/>
-        </p:nvSpPr>
-        <p:spPr>
-          <a:xfrm>
-            <a:off x="6281928" y="1463040"/>
-            <a:ext cx="2194560" cy="274320"/>
-          </a:xfrm>
-          <a:prstGeom prst="rect">
-            <a:avLst/>
-          </a:prstGeom>
-          <a:noFill/>
-          <a:ln/>
-        </p:spPr>
-        <p:txBody>
-          <a:bodyPr wrap="square" lIns="0" tIns="0" rIns="0" bIns="0" rtlCol="0" anchor="ctr"/>
-          <a:lstStyle/>
-          <a:p>
-            <a:pPr indent="0" marL="0">
-              <a:buNone/>
-            </a:pPr>
-            <a:r>
-              <a:rPr lang="en-US" sz="1050" b="1" spc="200" kern="0" dirty="0">
-                <a:solidFill>
-                  <a:srgbClr val="2DD4BF"/>
-                </a:solidFill>
-                <a:latin typeface="Trebuchet MS" pitchFamily="34" charset="0"/>
-                <a:ea typeface="Trebuchet MS" pitchFamily="34" charset="-122"/>
-                <a:cs typeface="Trebuchet MS" pitchFamily="34" charset="-120"/>
-              </a:rPr>
               <a:t>WHY IT WORKS</a:t>
             </a:r>
             <a:endParaRPr lang="en-US" sz="1050" dirty="0"/>
@@ -11536,7 +11693,7 @@
       </p:sp>
       <p:sp>
         <p:nvSpPr>
-          <p:cNvPr id="22" name="Text 20"/>
+          <p:cNvPr id="27" name="Text 25"/>
           <p:cNvSpPr/>
           <p:nvPr/>
         </p:nvSpPr>
@@ -11621,7 +11778,7 @@
       </p:sp>
       <p:sp>
         <p:nvSpPr>
-          <p:cNvPr id="23" name="Text 21"/>
+          <p:cNvPr id="28" name="Text 26"/>
           <p:cNvSpPr/>
           <p:nvPr/>
         </p:nvSpPr>

</xml_diff>

<commit_message>
Adapt deck competitive narrative for post-launch ICP
- Slide 9: reframe 2x2 from pre/post-launch timing to layer (windshield vs
  record-keeping) x migration; moat is now structural, not a timing window
- Slide 3: wedge renamed "First-Year Financial Clarity" (retire launch/transition smell)
- Slide 5 + 14: relabel wedge as "first year" practices; tighten incumbent contrast
- Pitch package positioning section reframed to match

Co-Authored-By: Claude Opus 4.8 <noreply@anthropic.com>
</commit_message>
<xml_diff>
--- a/docs/fundraising/pitch-deck-2026-06-11-softbank-necx.pptx
+++ b/docs/fundraising/pitch-deck-2026-06-11-softbank-necx.pptx
@@ -849,7 +849,7 @@
           <a:p>
             <a:r>
               <a:rPr lang="en-US" dirty="0"/>
-              <a:t>Map the field on two axes: pre- versus post-launch, productized versus not. Tebra, Jane, WebPT, athenahealth — all productized, all post-launch, all requiring EHR migration. Consultants serve pre-launch but at $30 to 60K, hourly and referral-gated. The pre-launch, productized quadrant is empty — that's our entry. And structurally they can't follow: their revenue starts at go-live, ours starts 18 months earlier. If asked: yes, a practicing dermatologist we interviewed is exploring a similar build — that's the ICP validating the market from the inside, single-specialty and part-time.</a:t>
+              <a:t>Map the field on two axes that actually matter: do you guide the next decision, or just record the last one — and do you require a migration to deliver it. Tebra, Jane, athenahealth, WebPT are systems of record you migrate onto. Outsourced billing and spreadsheets sit alongside but only record. Enterprise RCM and the $30-60K consultants give real intelligence, but they're heavy, manual, and built for big systems. The windshield-plus-no-migration quadrant is empty — that's us: a forward-looking financial brain that runs on top of the stack a first-year independent already has. The moat is the layer and the data, not a calendar window. If asked: yes, a practicing dermatologist we interviewed is exploring a similar build — the ICP validating the market from the inside, single-specialty and part-time.</a:t>
             </a:r>
             <a:endParaRPr lang="en-US" dirty="0"/>
           </a:p>
@@ -1729,7 +1729,7 @@
           <a:p>
             <a:r>
               <a:rPr lang="en-US" dirty="0"/>
-              <a:t>Sizing is layered and conservative. The macro: US RCM is $65 billion headed to $196 billion by 2035. Our serviceable layer: 100,000 independent practices at $4,800 a year is $480 million. The wedge entry: 5 to 10 thousand new launches a year. And the honest trend, said before you ask: independent share fell from 60 to 42 percent — which is exactly why today's independents are the conviction cohort, with DPC growing double digits.</a:t>
+              <a:t>Sizing is layered and conservative. The macro: US RCM is $65 billion headed to $196 billion by 2035. Our serviceable layer: 100,000 independent practices at $4,800 a year is $480 million. The wedge entry: 5 to 10 thousand practices in their first year, every year — the moment the financial pain is acute. And the honest trend, said before you ask: independent share fell from 60 to 42 percent — which is exactly why today's independents are the conviction cohort, with DPC growing double digits.</a:t>
             </a:r>
             <a:endParaRPr lang="en-US" dirty="0"/>
           </a:p>
@@ -2747,7 +2747,7 @@
               <a:buNone/>
             </a:pPr>
             <a:r>
-              <a:rPr lang="en-US" sz="2400" b="1" dirty="0">
+              <a:rPr lang="en-US" sz="2100" b="1" dirty="0">
                 <a:solidFill>
                   <a:srgbClr val="FFFFFF"/>
                 </a:solidFill>
@@ -2755,9 +2755,9 @@
                 <a:ea typeface="Trebuchet MS" pitchFamily="34" charset="-122"/>
                 <a:cs typeface="Trebuchet MS" pitchFamily="34" charset="-120"/>
               </a:rPr>
-              <a:t>Everyone else starts the day the clinic opens.</a:t>
-            </a:r>
-            <a:endParaRPr lang="en-US" sz="2400" dirty="0"/>
+              <a:t>Everyone else records the past. We run the next decision.</a:t>
+            </a:r>
+            <a:endParaRPr lang="en-US" sz="2100" dirty="0"/>
           </a:p>
         </p:txBody>
       </p:sp>
@@ -2792,8 +2792,8 @@
         </p:nvSpPr>
         <p:spPr>
           <a:xfrm>
-            <a:off x="2971800" y="1325880"/>
-            <a:ext cx="0" cy="3017520"/>
+            <a:off x="2971800" y="1371600"/>
+            <a:ext cx="0" cy="2926080"/>
           </a:xfrm>
           <a:prstGeom prst="line">
             <a:avLst/>
@@ -2815,8 +2815,8 @@
         </p:nvSpPr>
         <p:spPr>
           <a:xfrm>
-            <a:off x="2286000" y="1069848"/>
-            <a:ext cx="1371600" cy="201168"/>
+            <a:off x="1508760" y="1124712"/>
+            <a:ext cx="2926080" cy="201168"/>
           </a:xfrm>
           <a:prstGeom prst="rect">
             <a:avLst/>
@@ -2832,17 +2832,17 @@
               <a:buNone/>
             </a:pPr>
             <a:r>
-              <a:rPr lang="en-US" sz="850" spc="200" kern="0" dirty="0">
-                <a:solidFill>
-                  <a:srgbClr val="8FA3BF"/>
+              <a:rPr lang="en-US" sz="750" spc="100" kern="0" dirty="0">
+                <a:solidFill>
+                  <a:srgbClr val="5EEAD4"/>
                 </a:solidFill>
                 <a:latin typeface="Trebuchet MS" pitchFamily="34" charset="0"/>
                 <a:ea typeface="Trebuchet MS" pitchFamily="34" charset="-122"/>
                 <a:cs typeface="Trebuchet MS" pitchFamily="34" charset="-120"/>
               </a:rPr>
-              <a:t>PRODUCTIZED</a:t>
-            </a:r>
-            <a:endParaRPr lang="en-US" sz="850" dirty="0"/>
+              <a:t>DECISION INTELLIGENCE · WINDSHIELD</a:t>
+            </a:r>
+            <a:endParaRPr lang="en-US" sz="750" dirty="0"/>
           </a:p>
         </p:txBody>
       </p:sp>
@@ -2854,8 +2854,8 @@
         </p:nvSpPr>
         <p:spPr>
           <a:xfrm>
-            <a:off x="2286000" y="4398264"/>
-            <a:ext cx="1371600" cy="201168"/>
+            <a:off x="1508760" y="4343400"/>
+            <a:ext cx="2926080" cy="201168"/>
           </a:xfrm>
           <a:prstGeom prst="rect">
             <a:avLst/>
@@ -2871,7 +2871,7 @@
               <a:buNone/>
             </a:pPr>
             <a:r>
-              <a:rPr lang="en-US" sz="850" spc="200" kern="0" dirty="0">
+              <a:rPr lang="en-US" sz="750" spc="100" kern="0" dirty="0">
                 <a:solidFill>
                   <a:srgbClr val="8FA3BF"/>
                 </a:solidFill>
@@ -2879,9 +2879,9 @@
                 <a:ea typeface="Trebuchet MS" pitchFamily="34" charset="-122"/>
                 <a:cs typeface="Trebuchet MS" pitchFamily="34" charset="-120"/>
               </a:rPr>
-              <a:t>UNPRODUCTIZED</a:t>
-            </a:r>
-            <a:endParaRPr lang="en-US" sz="850" dirty="0"/>
+              <a:t>RECORD-KEEPING · REAR-VIEW</a:t>
+            </a:r>
+            <a:endParaRPr lang="en-US" sz="750" dirty="0"/>
           </a:p>
         </p:txBody>
       </p:sp>
@@ -2893,24 +2893,24 @@
         </p:nvSpPr>
         <p:spPr>
           <a:xfrm>
-            <a:off x="438912" y="2560320"/>
-            <a:ext cx="1188720" cy="201168"/>
-          </a:xfrm>
-          <a:prstGeom prst="rect">
-            <a:avLst/>
-          </a:prstGeom>
-          <a:noFill/>
-          <a:ln/>
-        </p:spPr>
-        <p:txBody>
-          <a:bodyPr wrap="square" lIns="0" tIns="0" rIns="0" bIns="0" rtlCol="0" anchor="ctr"/>
-          <a:lstStyle/>
-          <a:p>
-            <a:pPr indent="0" marL="0">
-              <a:buNone/>
-            </a:pPr>
-            <a:r>
-              <a:rPr lang="en-US" sz="850" spc="200" kern="0" dirty="0">
+            <a:off x="384048" y="2542032"/>
+            <a:ext cx="914400" cy="457200"/>
+          </a:xfrm>
+          <a:prstGeom prst="rect">
+            <a:avLst/>
+          </a:prstGeom>
+          <a:noFill/>
+          <a:ln/>
+        </p:spPr>
+        <p:txBody>
+          <a:bodyPr wrap="square" lIns="0" tIns="0" rIns="0" bIns="0" rtlCol="0" anchor="ctr"/>
+          <a:lstStyle/>
+          <a:p>
+            <a:pPr indent="0" marL="0">
+              <a:buNone/>
+            </a:pPr>
+            <a:r>
+              <a:rPr lang="en-US" sz="750" spc="100" kern="0" dirty="0">
                 <a:solidFill>
                   <a:srgbClr val="8FA3BF"/>
                 </a:solidFill>
@@ -2918,38 +2918,16 @@
                 <a:ea typeface="Trebuchet MS" pitchFamily="34" charset="-122"/>
                 <a:cs typeface="Trebuchet MS" pitchFamily="34" charset="-120"/>
               </a:rPr>
-              <a:t>POST-LAUNCH</a:t>
-            </a:r>
-            <a:endParaRPr lang="en-US" sz="850" dirty="0"/>
-          </a:p>
-        </p:txBody>
-      </p:sp>
-      <p:sp>
-        <p:nvSpPr>
-          <p:cNvPr id="9" name="Text 7"/>
-          <p:cNvSpPr/>
-          <p:nvPr/>
-        </p:nvSpPr>
-        <p:spPr>
-          <a:xfrm>
-            <a:off x="4315968" y="2560320"/>
-            <a:ext cx="1188720" cy="201168"/>
-          </a:xfrm>
-          <a:prstGeom prst="rect">
-            <a:avLst/>
-          </a:prstGeom>
-          <a:noFill/>
-          <a:ln/>
-        </p:spPr>
-        <p:txBody>
-          <a:bodyPr wrap="square" lIns="0" tIns="0" rIns="0" bIns="0" rtlCol="0" anchor="ctr"/>
-          <a:lstStyle/>
-          <a:p>
-            <a:pPr algn="r" indent="0" marL="0">
-              <a:buNone/>
-            </a:pPr>
-            <a:r>
-              <a:rPr lang="en-US" sz="850" spc="200" kern="0" dirty="0">
+              <a:t>MIGRATION</a:t>
+            </a:r>
+            <a:endParaRPr lang="en-US" sz="750" dirty="0"/>
+          </a:p>
+          <a:p>
+            <a:pPr indent="0" marL="0">
+              <a:buNone/>
+            </a:pPr>
+            <a:r>
+              <a:rPr lang="en-US" sz="750" spc="100" kern="0" dirty="0">
                 <a:solidFill>
                   <a:srgbClr val="8FA3BF"/>
                 </a:solidFill>
@@ -2957,9 +2935,65 @@
                 <a:ea typeface="Trebuchet MS" pitchFamily="34" charset="-122"/>
                 <a:cs typeface="Trebuchet MS" pitchFamily="34" charset="-120"/>
               </a:rPr>
-              <a:t>PRE-LAUNCH</a:t>
-            </a:r>
-            <a:endParaRPr lang="en-US" sz="850" dirty="0"/>
+              <a:t>REQUIRED</a:t>
+            </a:r>
+            <a:endParaRPr lang="en-US" sz="750" dirty="0"/>
+          </a:p>
+        </p:txBody>
+      </p:sp>
+      <p:sp>
+        <p:nvSpPr>
+          <p:cNvPr id="9" name="Text 7"/>
+          <p:cNvSpPr/>
+          <p:nvPr/>
+        </p:nvSpPr>
+        <p:spPr>
+          <a:xfrm>
+            <a:off x="4617720" y="2542032"/>
+            <a:ext cx="914400" cy="457200"/>
+          </a:xfrm>
+          <a:prstGeom prst="rect">
+            <a:avLst/>
+          </a:prstGeom>
+          <a:noFill/>
+          <a:ln/>
+        </p:spPr>
+        <p:txBody>
+          <a:bodyPr wrap="square" lIns="0" tIns="0" rIns="0" bIns="0" rtlCol="0" anchor="ctr"/>
+          <a:lstStyle/>
+          <a:p>
+            <a:pPr algn="r" indent="0" marL="0">
+              <a:buNone/>
+            </a:pPr>
+            <a:r>
+              <a:rPr lang="en-US" sz="750" spc="100" kern="0" dirty="0">
+                <a:solidFill>
+                  <a:srgbClr val="8FA3BF"/>
+                </a:solidFill>
+                <a:latin typeface="Trebuchet MS" pitchFamily="34" charset="0"/>
+                <a:ea typeface="Trebuchet MS" pitchFamily="34" charset="-122"/>
+                <a:cs typeface="Trebuchet MS" pitchFamily="34" charset="-120"/>
+              </a:rPr>
+              <a:t>NO</a:t>
+            </a:r>
+            <a:endParaRPr lang="en-US" sz="750" dirty="0"/>
+          </a:p>
+          <a:p>
+            <a:pPr algn="r" indent="0" marL="0">
+              <a:buNone/>
+            </a:pPr>
+            <a:r>
+              <a:rPr lang="en-US" sz="750" spc="100" kern="0" dirty="0">
+                <a:solidFill>
+                  <a:srgbClr val="8FA3BF"/>
+                </a:solidFill>
+                <a:latin typeface="Trebuchet MS" pitchFamily="34" charset="0"/>
+                <a:ea typeface="Trebuchet MS" pitchFamily="34" charset="-122"/>
+                <a:cs typeface="Trebuchet MS" pitchFamily="34" charset="-120"/>
+              </a:rPr>
+              <a:t>MIGRATION</a:t>
+            </a:r>
+            <a:endParaRPr lang="en-US" sz="750" dirty="0"/>
           </a:p>
         </p:txBody>
       </p:sp>
@@ -2971,8 +3005,8 @@
         </p:nvSpPr>
         <p:spPr>
           <a:xfrm>
-            <a:off x="685800" y="1645920"/>
-            <a:ext cx="2103120" cy="777240"/>
+            <a:off x="685800" y="1664208"/>
+            <a:ext cx="2057400" cy="777240"/>
           </a:xfrm>
           <a:prstGeom prst="rect">
             <a:avLst/>
@@ -2988,7 +3022,7 @@
               <a:buNone/>
             </a:pPr>
             <a:r>
-              <a:rPr lang="en-US" sz="1050" dirty="0">
+              <a:rPr lang="en-US" sz="950" dirty="0">
                 <a:solidFill>
                   <a:srgbClr val="8FA3BF"/>
                 </a:solidFill>
@@ -2996,16 +3030,16 @@
                 <a:ea typeface="Calibri" pitchFamily="34" charset="-122"/>
                 <a:cs typeface="Calibri" pitchFamily="34" charset="-120"/>
               </a:rPr>
-              <a:t>Tebra ($250M)  ·  Jane App ($1.8B)</a:t>
-            </a:r>
-            <a:endParaRPr lang="en-US" sz="1050" dirty="0"/>
-          </a:p>
-          <a:p>
-            <a:pPr indent="0" marL="0">
-              <a:buNone/>
-            </a:pPr>
-            <a:r>
-              <a:rPr lang="en-US" sz="1050" dirty="0">
+              <a:t>Enterprise RCM / BI (R1-tier)</a:t>
+            </a:r>
+            <a:endParaRPr lang="en-US" sz="950" dirty="0"/>
+          </a:p>
+          <a:p>
+            <a:pPr indent="0" marL="0">
+              <a:buNone/>
+            </a:pPr>
+            <a:r>
+              <a:rPr lang="en-US" sz="950" dirty="0">
                 <a:solidFill>
                   <a:srgbClr val="8FA3BF"/>
                 </a:solidFill>
@@ -3013,9 +3047,9 @@
                 <a:ea typeface="Calibri" pitchFamily="34" charset="-122"/>
                 <a:cs typeface="Calibri" pitchFamily="34" charset="-120"/>
               </a:rPr>
-              <a:t>WebPT · athenahealth · Meroka</a:t>
-            </a:r>
-            <a:endParaRPr lang="en-US" sz="1050" dirty="0"/>
+              <a:t>$30–60K consultants — heavy, manual</a:t>
+            </a:r>
+            <a:endParaRPr lang="en-US" sz="950" dirty="0"/>
           </a:p>
         </p:txBody>
       </p:sp>
@@ -3027,8 +3061,8 @@
         </p:nvSpPr>
         <p:spPr>
           <a:xfrm>
-            <a:off x="685800" y="3108960"/>
-            <a:ext cx="2103120" cy="640080"/>
+            <a:off x="685800" y="3090672"/>
+            <a:ext cx="2057400" cy="731520"/>
           </a:xfrm>
           <a:prstGeom prst="rect">
             <a:avLst/>
@@ -3044,7 +3078,7 @@
               <a:buNone/>
             </a:pPr>
             <a:r>
-              <a:rPr lang="en-US" sz="1050" dirty="0">
+              <a:rPr lang="en-US" sz="950" dirty="0">
                 <a:solidFill>
                   <a:srgbClr val="8FA3BF"/>
                 </a:solidFill>
@@ -3052,16 +3086,16 @@
                 <a:ea typeface="Calibri" pitchFamily="34" charset="-122"/>
                 <a:cs typeface="Calibri" pitchFamily="34" charset="-120"/>
               </a:rPr>
-              <a:t>Outsourced billing</a:t>
-            </a:r>
-            <a:endParaRPr lang="en-US" sz="1050" dirty="0"/>
-          </a:p>
-          <a:p>
-            <a:pPr indent="0" marL="0">
-              <a:buNone/>
-            </a:pPr>
-            <a:r>
-              <a:rPr lang="en-US" sz="1050" dirty="0">
+              <a:t>Tebra ($250M) · Jane ($1.8B)</a:t>
+            </a:r>
+            <a:endParaRPr lang="en-US" sz="950" dirty="0"/>
+          </a:p>
+          <a:p>
+            <a:pPr indent="0" marL="0">
+              <a:buNone/>
+            </a:pPr>
+            <a:r>
+              <a:rPr lang="en-US" sz="950" dirty="0">
                 <a:solidFill>
                   <a:srgbClr val="8FA3BF"/>
                 </a:solidFill>
@@ -3069,9 +3103,9 @@
                 <a:ea typeface="Calibri" pitchFamily="34" charset="-122"/>
                 <a:cs typeface="Calibri" pitchFamily="34" charset="-120"/>
               </a:rPr>
-              <a:t>Spreadsheets + inertia</a:t>
-            </a:r>
-            <a:endParaRPr lang="en-US" sz="1050" dirty="0"/>
+              <a:t>athenahealth · WebPT</a:t>
+            </a:r>
+            <a:endParaRPr lang="en-US" sz="950" dirty="0"/>
           </a:p>
         </p:txBody>
       </p:sp>
@@ -3083,8 +3117,8 @@
         </p:nvSpPr>
         <p:spPr>
           <a:xfrm>
-            <a:off x="3200400" y="3108960"/>
-            <a:ext cx="2103120" cy="640080"/>
+            <a:off x="3200400" y="3090672"/>
+            <a:ext cx="2057400" cy="731520"/>
           </a:xfrm>
           <a:prstGeom prst="rect">
             <a:avLst/>
@@ -3100,7 +3134,7 @@
               <a:buNone/>
             </a:pPr>
             <a:r>
-              <a:rPr lang="en-US" sz="1050" dirty="0">
+              <a:rPr lang="en-US" sz="950" dirty="0">
                 <a:solidFill>
                   <a:srgbClr val="8FA3BF"/>
                 </a:solidFill>
@@ -3108,16 +3142,16 @@
                 <a:ea typeface="Calibri" pitchFamily="34" charset="-122"/>
                 <a:cs typeface="Calibri" pitchFamily="34" charset="-120"/>
               </a:rPr>
-              <a:t>Startup consultants</a:t>
-            </a:r>
-            <a:endParaRPr lang="en-US" sz="1050" dirty="0"/>
-          </a:p>
-          <a:p>
-            <a:pPr indent="0" marL="0">
-              <a:buNone/>
-            </a:pPr>
-            <a:r>
-              <a:rPr lang="en-US" sz="1050" dirty="0">
+              <a:t>Outsourced billing</a:t>
+            </a:r>
+            <a:endParaRPr lang="en-US" sz="950" dirty="0"/>
+          </a:p>
+          <a:p>
+            <a:pPr indent="0" marL="0">
+              <a:buNone/>
+            </a:pPr>
+            <a:r>
+              <a:rPr lang="en-US" sz="950" dirty="0">
                 <a:solidFill>
                   <a:srgbClr val="8FA3BF"/>
                 </a:solidFill>
@@ -3125,9 +3159,9 @@
                 <a:ea typeface="Calibri" pitchFamily="34" charset="-122"/>
                 <a:cs typeface="Calibri" pitchFamily="34" charset="-120"/>
               </a:rPr>
-              <a:t>$30K–$60K, hourly, referral-gated</a:t>
-            </a:r>
-            <a:endParaRPr lang="en-US" sz="1050" dirty="0"/>
+              <a:t>Spreadsheets + inertia</a:t>
+            </a:r>
+            <a:endParaRPr lang="en-US" sz="950" dirty="0"/>
           </a:p>
         </p:txBody>
       </p:sp>
@@ -3139,7 +3173,7 @@
         </p:nvSpPr>
         <p:spPr>
           <a:xfrm>
-            <a:off x="3291840" y="1691640"/>
+            <a:off x="3291840" y="1755648"/>
             <a:ext cx="1920240" cy="685800"/>
           </a:xfrm>
           <a:prstGeom prst="rect">
@@ -3159,7 +3193,7 @@
         </p:nvSpPr>
         <p:spPr>
           <a:xfrm>
-            <a:off x="3291840" y="1691640"/>
+            <a:off x="3291840" y="1755648"/>
             <a:ext cx="1920240" cy="685800"/>
           </a:xfrm>
           <a:prstGeom prst="rect">
@@ -3198,8 +3232,8 @@
         </p:nvSpPr>
         <p:spPr>
           <a:xfrm>
-            <a:off x="5760720" y="1325880"/>
-            <a:ext cx="2926080" cy="3017520"/>
+            <a:off x="5760720" y="1371600"/>
+            <a:ext cx="2926080" cy="2926080"/>
           </a:xfrm>
           <a:prstGeom prst="rect">
             <a:avLst/>
@@ -3218,7 +3252,7 @@
         </p:nvSpPr>
         <p:spPr>
           <a:xfrm>
-            <a:off x="5961888" y="1508760"/>
+            <a:off x="5961888" y="1536192"/>
             <a:ext cx="2514600" cy="274320"/>
           </a:xfrm>
           <a:prstGeom prst="rect">
@@ -3257,8 +3291,8 @@
         </p:nvSpPr>
         <p:spPr>
           <a:xfrm>
-            <a:off x="5961888" y="1856232"/>
-            <a:ext cx="2514600" cy="2377440"/>
+            <a:off x="5961888" y="1865376"/>
+            <a:ext cx="2514600" cy="2331720"/>
           </a:xfrm>
           <a:prstGeom prst="rect">
             <a:avLst/>
@@ -3272,13 +3306,13 @@
           <a:p>
             <a:pPr marL="342900" indent="-342900">
               <a:spcAft>
-                <a:spcPts val="900"/>
+                <a:spcPts val="800"/>
               </a:spcAft>
               <a:buSzPct val="100000"/>
               <a:buChar char="•"/>
             </a:pPr>
             <a:r>
-              <a:rPr lang="en-US" sz="1100" dirty="0">
+              <a:rPr lang="en-US" sz="1050" dirty="0">
                 <a:solidFill>
                   <a:srgbClr val="FFFFFF"/>
                 </a:solidFill>
@@ -3286,20 +3320,20 @@
                 <a:ea typeface="Calibri" pitchFamily="34" charset="-122"/>
                 <a:cs typeface="Calibri" pitchFamily="34" charset="-120"/>
               </a:rPr>
-              <a:t>Incumbent revenue begins at go-live: onboarding fees, per-provider subs, clearinghouse cuts</a:t>
-            </a:r>
-            <a:endParaRPr lang="en-US" sz="1100" dirty="0"/>
+              <a:t>Incumbents are systems of record — they log what happened; they don't guide the next decision</a:t>
+            </a:r>
+            <a:endParaRPr lang="en-US" sz="1050" dirty="0"/>
           </a:p>
           <a:p>
             <a:pPr marL="342900" indent="-342900">
               <a:spcAft>
-                <a:spcPts val="900"/>
+                <a:spcPts val="800"/>
               </a:spcAft>
               <a:buSzPct val="100000"/>
               <a:buChar char="•"/>
             </a:pPr>
             <a:r>
-              <a:rPr lang="en-US" sz="1100" dirty="0">
+              <a:rPr lang="en-US" sz="1050" dirty="0">
                 <a:solidFill>
                   <a:srgbClr val="FFFFFF"/>
                 </a:solidFill>
@@ -3307,20 +3341,20 @@
                 <a:ea typeface="Calibri" pitchFamily="34" charset="-122"/>
                 <a:cs typeface="Calibri" pitchFamily="34" charset="-120"/>
               </a:rPr>
-              <a:t>The 18 months before go-live are structurally invisible to their model</a:t>
-            </a:r>
-            <a:endParaRPr lang="en-US" sz="1100" dirty="0"/>
+              <a:t>Their model depends on you migrating onto them; we sit on top of the stack you already run</a:t>
+            </a:r>
+            <a:endParaRPr lang="en-US" sz="1050" dirty="0"/>
           </a:p>
           <a:p>
             <a:pPr marL="342900" indent="-342900">
               <a:spcAft>
-                <a:spcPts val="900"/>
+                <a:spcPts val="800"/>
               </a:spcAft>
               <a:buSzPct val="100000"/>
               <a:buChar char="•"/>
             </a:pPr>
             <a:r>
-              <a:rPr lang="en-US" sz="1100" dirty="0">
+              <a:rPr lang="en-US" sz="1050" dirty="0">
                 <a:solidFill>
                   <a:srgbClr val="FFFFFF"/>
                 </a:solidFill>
@@ -3328,9 +3362,9 @@
                 <a:ea typeface="Calibri" pitchFamily="34" charset="-122"/>
                 <a:cs typeface="Calibri" pitchFamily="34" charset="-120"/>
               </a:rPr>
-              <a:t>We never ask a practice to migrate its EHR — their #1 purchase objection is our entry path</a:t>
-            </a:r>
-            <a:endParaRPr lang="en-US" sz="1100" dirty="0"/>
+              <a:t>Real-time financial intelligence has only existed for hospital systems — never the first-year independent</a:t>
+            </a:r>
+            <a:endParaRPr lang="en-US" sz="1050" dirty="0"/>
           </a:p>
         </p:txBody>
       </p:sp>
@@ -6207,7 +6241,7 @@
                 <a:ea typeface="Calibri" pitchFamily="34" charset="-122"/>
                 <a:cs typeface="Calibri" pitchFamily="34" charset="-120"/>
               </a:rPr>
-              <a:t>The conviction cohort grows (DPC +10–15%/yr) while incumbents chase post-launch retention</a:t>
+              <a:t>The conviction cohort grows (DPC +10–15%/yr) while incumbents chase established multi-year practices — the first year is ours</a:t>
             </a:r>
             <a:endParaRPr lang="en-US" sz="1050" dirty="0"/>
           </a:p>
@@ -7840,7 +7874,7 @@
               <a:buNone/>
             </a:pPr>
             <a:r>
-              <a:rPr lang="en-US" sz="1700" b="1" dirty="0">
+              <a:rPr lang="en-US" sz="1600" b="1" dirty="0">
                 <a:solidFill>
                   <a:srgbClr val="FFFFFF"/>
                 </a:solidFill>
@@ -7848,9 +7882,9 @@
                 <a:ea typeface="Trebuchet MS" pitchFamily="34" charset="-122"/>
                 <a:cs typeface="Trebuchet MS" pitchFamily="34" charset="-120"/>
               </a:rPr>
-              <a:t>PhysicianLabs Launch</a:t>
-            </a:r>
-            <a:endParaRPr lang="en-US" sz="1700" dirty="0"/>
+              <a:t>First-Year Financial Clarity</a:t>
+            </a:r>
+            <a:endParaRPr lang="en-US" sz="1600" dirty="0"/>
           </a:p>
         </p:txBody>
       </p:sp>
@@ -9259,7 +9293,7 @@
                 <a:ea typeface="Calibri" pitchFamily="34" charset="-122"/>
                 <a:cs typeface="Calibri" pitchFamily="34" charset="-120"/>
               </a:rPr>
-              <a:t>wedge entry: 5–10K new practice launches every year</a:t>
+              <a:t>wedge entry: 5–10K practices in their first year, every year</a:t>
             </a:r>
             <a:endParaRPr lang="en-US" sz="1100" dirty="0"/>
           </a:p>

</xml_diff>

<commit_message>
Add competitor comparison matrix slide (appendix)
5 parameters x 6 competitors + PhysicianLabs, navy/teal style. Honest matrix:
PhysicianLabs wins the top 4 structural rows, concedes installed base/specialty
depth. Appended as standalone slide for tomorrow's deck / Q&A backup.

Co-Authored-By: Claude Opus 4.8 <noreply@anthropic.com>
</commit_message>
<xml_diff>
--- a/docs/fundraising/pitch-deck-2026-06-11-softbank-necx.pptx
+++ b/docs/fundraising/pitch-deck-2026-06-11-softbank-necx.pptx
@@ -20,9 +20,10 @@
     <p:sldId id="268" r:id="rId14"/>
     <p:sldId id="269" r:id="rId15"/>
     <p:sldId id="270" r:id="rId16"/>
+    <p:sldId id="271" r:id="rId17"/>
   </p:sldIdLst>
   <p:notesMasterIdLst>
-    <p:notesMasterId r:id="rId17"/>
+    <p:notesMasterId r:id="rId18"/>
   </p:notesMasterIdLst>
   <p:sldSz cx="9144000" cy="5143500"/>
   <p:notesSz cx="5143500" cy="9144000"/>
@@ -1313,6 +1314,94 @@
             <a:fld id="{F7021451-1387-4CA6-816F-3879F97B5CBC}" type="slidenum">
               <a:rPr lang="en-US"/>
               <a:t>15</a:t>
+            </a:fld>
+            <a:endParaRPr lang="en-US"/>
+          </a:p>
+        </p:txBody>
+      </p:sp>
+    </p:spTree>
+    <p:extLst>
+      <p:ext uri="{BB962C8B-B14F-4D97-AF65-F5344CB8AC3E}">
+        <p14:creationId xmlns:p14="http://schemas.microsoft.com/office/powerpoint/2010/main" val="1024086991"/>
+      </p:ext>
+    </p:extLst>
+  </p:cSld>
+  <p:clrMapOvr>
+    <a:masterClrMapping/>
+  </p:clrMapOvr>
+</p:notes>
+</file>
+
+<file path=ppt/notesSlides/notesSlide16.xml><?xml version="1.0" encoding="utf-8"?>
+<p:notes xmlns:a="http://schemas.openxmlformats.org/drawingml/2006/main" xmlns:r="http://schemas.openxmlformats.org/officeDocument/2006/relationships" xmlns:p="http://schemas.openxmlformats.org/presentationml/2006/main">
+  <p:cSld>
+    <p:spTree>
+      <p:nvGrpSpPr>
+        <p:cNvPr id="1" name=""/>
+        <p:cNvGrpSpPr/>
+        <p:nvPr/>
+      </p:nvGrpSpPr>
+      <p:grpSpPr>
+        <a:xfrm>
+          <a:off x="0" y="0"/>
+          <a:ext cx="0" cy="0"/>
+          <a:chOff x="0" y="0"/>
+          <a:chExt cx="0" cy="0"/>
+        </a:xfrm>
+      </p:grpSpPr>
+      <p:sp>
+        <p:nvSpPr>
+          <p:cNvPr id="2" name="Slide Image Placeholder 1"/>
+          <p:cNvSpPr>
+            <a:spLocks noGrp="1" noRot="1" noChangeAspect="1"/>
+          </p:cNvSpPr>
+          <p:nvPr>
+            <p:ph type="sldImg"/>
+          </p:nvPr>
+        </p:nvSpPr>
+        <p:spPr/>
+      </p:sp>
+      <p:sp>
+        <p:nvSpPr>
+          <p:cNvPr id="3" name="Notes Placeholder 2"/>
+          <p:cNvSpPr>
+            <a:spLocks noGrp="1"/>
+          </p:cNvSpPr>
+          <p:nvPr>
+            <p:ph type="body" idx="1"/>
+          </p:nvPr>
+        </p:nvSpPr>
+        <p:spPr/>
+        <p:txBody>
+          <a:bodyPr/>
+          <a:lstStyle/>
+          <a:p>
+            <a:r>
+              <a:rPr lang="en-US" dirty="0"/>
+              <a:t>This is the detailed competitive view — use it as the competition slide, or hold it for Q&amp;A behind the 2x2. The read is simple: we're the only one delivering forward-looking financial intelligence, on top of existing tools, for the just-launched clinic, with ROI in dollars. The one row we don't win is installed base and specialty depth — and I'll name that proactively, because their installed base is exactly what makes the pre-launch and first-year window unattractive for them to chase. Status quo is spreadsheets plus an outsourced biller — the real default for a first-year doctor.</a:t>
+            </a:r>
+            <a:endParaRPr lang="en-US" dirty="0"/>
+          </a:p>
+        </p:txBody>
+      </p:sp>
+      <p:sp>
+        <p:nvSpPr>
+          <p:cNvPr id="4" name="Slide Number Placeholder 3"/>
+          <p:cNvSpPr>
+            <a:spLocks noGrp="1"/>
+          </p:cNvSpPr>
+          <p:nvPr>
+            <p:ph type="sldNum" sz="quarter" idx="10"/>
+          </p:nvPr>
+        </p:nvSpPr>
+        <p:spPr/>
+        <p:txBody>
+          <a:bodyPr/>
+          <a:lstStyle/>
+          <a:p>
+            <a:fld id="{F7021451-1387-4CA6-816F-3879F97B5CBC}" type="slidenum">
+              <a:rPr lang="en-US"/>
+              <a:t>16</a:t>
             </a:fld>
             <a:endParaRPr lang="en-US"/>
           </a:p>
@@ -6555,6 +6644,2208 @@
 </p:sld>
 </file>
 
+<file path=ppt/slides/slide16.xml><?xml version="1.0" encoding="utf-8"?>
+<p:sld xmlns:a="http://schemas.openxmlformats.org/drawingml/2006/main" xmlns:r="http://schemas.openxmlformats.org/officeDocument/2006/relationships" xmlns:p="http://schemas.openxmlformats.org/presentationml/2006/main">
+  <p:cSld name="Slide 16">
+    <p:bg>
+      <p:bgPr>
+        <a:solidFill>
+          <a:srgbClr val="0F172A"/>
+        </a:solidFill>
+      </p:bgPr>
+    </p:bg>
+    <p:spTree>
+      <p:nvGrpSpPr>
+        <p:cNvPr id="1" name=""/>
+        <p:cNvGrpSpPr/>
+        <p:nvPr/>
+      </p:nvGrpSpPr>
+      <p:grpSpPr>
+        <a:xfrm>
+          <a:off x="0" y="0"/>
+          <a:ext cx="0" cy="0"/>
+          <a:chOff x="0" y="0"/>
+          <a:chExt cx="0" cy="0"/>
+        </a:xfrm>
+      </p:grpSpPr>
+      <p:sp>
+        <p:nvSpPr>
+          <p:cNvPr id="2" name="Text 0"/>
+          <p:cNvSpPr/>
+          <p:nvPr/>
+        </p:nvSpPr>
+        <p:spPr>
+          <a:xfrm>
+            <a:off x="457200" y="274320"/>
+            <a:ext cx="6858000" cy="274320"/>
+          </a:xfrm>
+          <a:prstGeom prst="rect">
+            <a:avLst/>
+          </a:prstGeom>
+          <a:noFill/>
+          <a:ln/>
+        </p:spPr>
+        <p:txBody>
+          <a:bodyPr wrap="square" lIns="0" tIns="0" rIns="0" bIns="0" rtlCol="0" anchor="ctr"/>
+          <a:lstStyle/>
+          <a:p>
+            <a:pPr indent="0" marL="0">
+              <a:buNone/>
+            </a:pPr>
+            <a:r>
+              <a:rPr lang="en-US" sz="1000" b="1" spc="300" kern="0" dirty="0">
+                <a:solidFill>
+                  <a:srgbClr val="2DD4BF"/>
+                </a:solidFill>
+                <a:latin typeface="Trebuchet MS" pitchFamily="34" charset="0"/>
+                <a:ea typeface="Trebuchet MS" pitchFamily="34" charset="-122"/>
+                <a:cs typeface="Trebuchet MS" pitchFamily="34" charset="-120"/>
+              </a:rPr>
+              <a:t>APPENDIX  /  COMPETITIVE LANDSCAPE</a:t>
+            </a:r>
+            <a:endParaRPr lang="en-US" sz="1000" dirty="0"/>
+          </a:p>
+        </p:txBody>
+      </p:sp>
+      <p:sp>
+        <p:nvSpPr>
+          <p:cNvPr id="3" name="Text 1"/>
+          <p:cNvSpPr/>
+          <p:nvPr/>
+        </p:nvSpPr>
+        <p:spPr>
+          <a:xfrm>
+            <a:off x="457200" y="566928"/>
+            <a:ext cx="8229600" cy="502920"/>
+          </a:xfrm>
+          <a:prstGeom prst="rect">
+            <a:avLst/>
+          </a:prstGeom>
+          <a:noFill/>
+          <a:ln/>
+        </p:spPr>
+        <p:txBody>
+          <a:bodyPr wrap="square" lIns="0" tIns="0" rIns="0" bIns="0" rtlCol="0" anchor="ctr"/>
+          <a:lstStyle/>
+          <a:p>
+            <a:pPr indent="0" marL="0">
+              <a:buNone/>
+            </a:pPr>
+            <a:r>
+              <a:rPr lang="en-US" sz="2100" b="1" dirty="0">
+                <a:solidFill>
+                  <a:srgbClr val="FFFFFF"/>
+                </a:solidFill>
+                <a:latin typeface="Trebuchet MS" pitchFamily="34" charset="0"/>
+                <a:ea typeface="Trebuchet MS" pitchFamily="34" charset="-122"/>
+                <a:cs typeface="Trebuchet MS" pitchFamily="34" charset="-120"/>
+              </a:rPr>
+              <a:t>We own the rows that matter. Incumbents own the past.</a:t>
+            </a:r>
+            <a:endParaRPr lang="en-US" sz="2100" dirty="0"/>
+          </a:p>
+        </p:txBody>
+      </p:sp>
+      <p:sp>
+        <p:nvSpPr>
+          <p:cNvPr id="4" name="Shape 2"/>
+          <p:cNvSpPr/>
+          <p:nvPr/>
+        </p:nvSpPr>
+        <p:spPr>
+          <a:xfrm>
+            <a:off x="7479792" y="1325880"/>
+            <a:ext cx="960120" cy="3108960"/>
+          </a:xfrm>
+          <a:prstGeom prst="rect">
+            <a:avLst/>
+          </a:prstGeom>
+          <a:solidFill>
+            <a:srgbClr val="12303A"/>
+          </a:solidFill>
+          <a:ln/>
+        </p:spPr>
+      </p:sp>
+      <p:sp>
+        <p:nvSpPr>
+          <p:cNvPr id="5" name="Text 3"/>
+          <p:cNvSpPr/>
+          <p:nvPr/>
+        </p:nvSpPr>
+        <p:spPr>
+          <a:xfrm>
+            <a:off x="3200400" y="1325880"/>
+            <a:ext cx="713232" cy="457200"/>
+          </a:xfrm>
+          <a:prstGeom prst="rect">
+            <a:avLst/>
+          </a:prstGeom>
+          <a:noFill/>
+          <a:ln/>
+        </p:spPr>
+        <p:txBody>
+          <a:bodyPr wrap="square" lIns="0" tIns="0" rIns="0" bIns="0" rtlCol="0" anchor="ctr"/>
+          <a:lstStyle/>
+          <a:p>
+            <a:pPr algn="ctr" indent="0" marL="0">
+              <a:buNone/>
+            </a:pPr>
+            <a:r>
+              <a:rPr lang="en-US" sz="850" b="1" dirty="0">
+                <a:solidFill>
+                  <a:srgbClr val="8FA3BF"/>
+                </a:solidFill>
+                <a:latin typeface="Trebuchet MS" pitchFamily="34" charset="0"/>
+                <a:ea typeface="Trebuchet MS" pitchFamily="34" charset="-122"/>
+                <a:cs typeface="Trebuchet MS" pitchFamily="34" charset="-120"/>
+              </a:rPr>
+              <a:t>Tebra</a:t>
+            </a:r>
+            <a:endParaRPr lang="en-US" sz="850" dirty="0"/>
+          </a:p>
+        </p:txBody>
+      </p:sp>
+      <p:sp>
+        <p:nvSpPr>
+          <p:cNvPr id="6" name="Text 4"/>
+          <p:cNvSpPr/>
+          <p:nvPr/>
+        </p:nvSpPr>
+        <p:spPr>
+          <a:xfrm>
+            <a:off x="3913632" y="1325880"/>
+            <a:ext cx="713232" cy="457200"/>
+          </a:xfrm>
+          <a:prstGeom prst="rect">
+            <a:avLst/>
+          </a:prstGeom>
+          <a:noFill/>
+          <a:ln/>
+        </p:spPr>
+        <p:txBody>
+          <a:bodyPr wrap="square" lIns="0" tIns="0" rIns="0" bIns="0" rtlCol="0" anchor="ctr"/>
+          <a:lstStyle/>
+          <a:p>
+            <a:pPr algn="ctr" indent="0" marL="0">
+              <a:buNone/>
+            </a:pPr>
+            <a:r>
+              <a:rPr lang="en-US" sz="850" b="1" dirty="0">
+                <a:solidFill>
+                  <a:srgbClr val="8FA3BF"/>
+                </a:solidFill>
+                <a:latin typeface="Trebuchet MS" pitchFamily="34" charset="0"/>
+                <a:ea typeface="Trebuchet MS" pitchFamily="34" charset="-122"/>
+                <a:cs typeface="Trebuchet MS" pitchFamily="34" charset="-120"/>
+              </a:rPr>
+              <a:t>athena</a:t>
+            </a:r>
+            <a:endParaRPr lang="en-US" sz="850" dirty="0"/>
+          </a:p>
+        </p:txBody>
+      </p:sp>
+      <p:sp>
+        <p:nvSpPr>
+          <p:cNvPr id="7" name="Text 5"/>
+          <p:cNvSpPr/>
+          <p:nvPr/>
+        </p:nvSpPr>
+        <p:spPr>
+          <a:xfrm>
+            <a:off x="4626864" y="1325880"/>
+            <a:ext cx="713232" cy="457200"/>
+          </a:xfrm>
+          <a:prstGeom prst="rect">
+            <a:avLst/>
+          </a:prstGeom>
+          <a:noFill/>
+          <a:ln/>
+        </p:spPr>
+        <p:txBody>
+          <a:bodyPr wrap="square" lIns="0" tIns="0" rIns="0" bIns="0" rtlCol="0" anchor="ctr"/>
+          <a:lstStyle/>
+          <a:p>
+            <a:pPr algn="ctr" indent="0" marL="0">
+              <a:buNone/>
+            </a:pPr>
+            <a:r>
+              <a:rPr lang="en-US" sz="850" b="1" dirty="0">
+                <a:solidFill>
+                  <a:srgbClr val="8FA3BF"/>
+                </a:solidFill>
+                <a:latin typeface="Trebuchet MS" pitchFamily="34" charset="0"/>
+                <a:ea typeface="Trebuchet MS" pitchFamily="34" charset="-122"/>
+                <a:cs typeface="Trebuchet MS" pitchFamily="34" charset="-120"/>
+              </a:rPr>
+              <a:t>Jane</a:t>
+            </a:r>
+            <a:endParaRPr lang="en-US" sz="850" dirty="0"/>
+          </a:p>
+        </p:txBody>
+      </p:sp>
+      <p:sp>
+        <p:nvSpPr>
+          <p:cNvPr id="8" name="Text 6"/>
+          <p:cNvSpPr/>
+          <p:nvPr/>
+        </p:nvSpPr>
+        <p:spPr>
+          <a:xfrm>
+            <a:off x="5340096" y="1325880"/>
+            <a:ext cx="713232" cy="457200"/>
+          </a:xfrm>
+          <a:prstGeom prst="rect">
+            <a:avLst/>
+          </a:prstGeom>
+          <a:noFill/>
+          <a:ln/>
+        </p:spPr>
+        <p:txBody>
+          <a:bodyPr wrap="square" lIns="0" tIns="0" rIns="0" bIns="0" rtlCol="0" anchor="ctr"/>
+          <a:lstStyle/>
+          <a:p>
+            <a:pPr algn="ctr" indent="0" marL="0">
+              <a:buNone/>
+            </a:pPr>
+            <a:r>
+              <a:rPr lang="en-US" sz="850" b="1" dirty="0">
+                <a:solidFill>
+                  <a:srgbClr val="8FA3BF"/>
+                </a:solidFill>
+                <a:latin typeface="Trebuchet MS" pitchFamily="34" charset="0"/>
+                <a:ea typeface="Trebuchet MS" pitchFamily="34" charset="-122"/>
+                <a:cs typeface="Trebuchet MS" pitchFamily="34" charset="-120"/>
+              </a:rPr>
+              <a:t>Chiro-</a:t>
+            </a:r>
+            <a:endParaRPr lang="en-US" sz="850" dirty="0"/>
+          </a:p>
+          <a:p>
+            <a:pPr algn="ctr" indent="0" marL="0">
+              <a:buNone/>
+            </a:pPr>
+            <a:r>
+              <a:rPr lang="en-US" sz="850" b="1" dirty="0">
+                <a:solidFill>
+                  <a:srgbClr val="8FA3BF"/>
+                </a:solidFill>
+                <a:latin typeface="Trebuchet MS" pitchFamily="34" charset="0"/>
+                <a:ea typeface="Trebuchet MS" pitchFamily="34" charset="-122"/>
+                <a:cs typeface="Trebuchet MS" pitchFamily="34" charset="-120"/>
+              </a:rPr>
+              <a:t>Touch</a:t>
+            </a:r>
+            <a:endParaRPr lang="en-US" sz="850" dirty="0"/>
+          </a:p>
+        </p:txBody>
+      </p:sp>
+      <p:sp>
+        <p:nvSpPr>
+          <p:cNvPr id="9" name="Text 7"/>
+          <p:cNvSpPr/>
+          <p:nvPr/>
+        </p:nvSpPr>
+        <p:spPr>
+          <a:xfrm>
+            <a:off x="6053328" y="1325880"/>
+            <a:ext cx="713232" cy="457200"/>
+          </a:xfrm>
+          <a:prstGeom prst="rect">
+            <a:avLst/>
+          </a:prstGeom>
+          <a:noFill/>
+          <a:ln/>
+        </p:spPr>
+        <p:txBody>
+          <a:bodyPr wrap="square" lIns="0" tIns="0" rIns="0" bIns="0" rtlCol="0" anchor="ctr"/>
+          <a:lstStyle/>
+          <a:p>
+            <a:pPr algn="ctr" indent="0" marL="0">
+              <a:buNone/>
+            </a:pPr>
+            <a:r>
+              <a:rPr lang="en-US" sz="850" b="1" dirty="0">
+                <a:solidFill>
+                  <a:srgbClr val="8FA3BF"/>
+                </a:solidFill>
+                <a:latin typeface="Trebuchet MS" pitchFamily="34" charset="0"/>
+                <a:ea typeface="Trebuchet MS" pitchFamily="34" charset="-122"/>
+                <a:cs typeface="Trebuchet MS" pitchFamily="34" charset="-120"/>
+              </a:rPr>
+              <a:t>Meroka</a:t>
+            </a:r>
+            <a:endParaRPr lang="en-US" sz="850" dirty="0"/>
+          </a:p>
+        </p:txBody>
+      </p:sp>
+      <p:sp>
+        <p:nvSpPr>
+          <p:cNvPr id="10" name="Text 8"/>
+          <p:cNvSpPr/>
+          <p:nvPr/>
+        </p:nvSpPr>
+        <p:spPr>
+          <a:xfrm>
+            <a:off x="6766560" y="1325880"/>
+            <a:ext cx="713232" cy="457200"/>
+          </a:xfrm>
+          <a:prstGeom prst="rect">
+            <a:avLst/>
+          </a:prstGeom>
+          <a:noFill/>
+          <a:ln/>
+        </p:spPr>
+        <p:txBody>
+          <a:bodyPr wrap="square" lIns="0" tIns="0" rIns="0" bIns="0" rtlCol="0" anchor="ctr"/>
+          <a:lstStyle/>
+          <a:p>
+            <a:pPr algn="ctr" indent="0" marL="0">
+              <a:buNone/>
+            </a:pPr>
+            <a:r>
+              <a:rPr lang="en-US" sz="850" b="1" dirty="0">
+                <a:solidFill>
+                  <a:srgbClr val="8FA3BF"/>
+                </a:solidFill>
+                <a:latin typeface="Trebuchet MS" pitchFamily="34" charset="0"/>
+                <a:ea typeface="Trebuchet MS" pitchFamily="34" charset="-122"/>
+                <a:cs typeface="Trebuchet MS" pitchFamily="34" charset="-120"/>
+              </a:rPr>
+              <a:t>Status</a:t>
+            </a:r>
+            <a:endParaRPr lang="en-US" sz="850" dirty="0"/>
+          </a:p>
+          <a:p>
+            <a:pPr algn="ctr" indent="0" marL="0">
+              <a:buNone/>
+            </a:pPr>
+            <a:r>
+              <a:rPr lang="en-US" sz="850" b="1" dirty="0">
+                <a:solidFill>
+                  <a:srgbClr val="8FA3BF"/>
+                </a:solidFill>
+                <a:latin typeface="Trebuchet MS" pitchFamily="34" charset="0"/>
+                <a:ea typeface="Trebuchet MS" pitchFamily="34" charset="-122"/>
+                <a:cs typeface="Trebuchet MS" pitchFamily="34" charset="-120"/>
+              </a:rPr>
+              <a:t>quo</a:t>
+            </a:r>
+            <a:endParaRPr lang="en-US" sz="850" dirty="0"/>
+          </a:p>
+        </p:txBody>
+      </p:sp>
+      <p:sp>
+        <p:nvSpPr>
+          <p:cNvPr id="11" name="Text 9"/>
+          <p:cNvSpPr/>
+          <p:nvPr/>
+        </p:nvSpPr>
+        <p:spPr>
+          <a:xfrm>
+            <a:off x="7479792" y="1325880"/>
+            <a:ext cx="960120" cy="457200"/>
+          </a:xfrm>
+          <a:prstGeom prst="rect">
+            <a:avLst/>
+          </a:prstGeom>
+          <a:noFill/>
+          <a:ln/>
+        </p:spPr>
+        <p:txBody>
+          <a:bodyPr wrap="square" lIns="0" tIns="0" rIns="0" bIns="0" rtlCol="0" anchor="ctr"/>
+          <a:lstStyle/>
+          <a:p>
+            <a:pPr algn="ctr" indent="0" marL="0">
+              <a:buNone/>
+            </a:pPr>
+            <a:r>
+              <a:rPr lang="en-US" sz="1000" b="1" dirty="0">
+                <a:solidFill>
+                  <a:srgbClr val="2DD4BF"/>
+                </a:solidFill>
+                <a:latin typeface="Trebuchet MS" pitchFamily="34" charset="0"/>
+                <a:ea typeface="Trebuchet MS" pitchFamily="34" charset="-122"/>
+                <a:cs typeface="Trebuchet MS" pitchFamily="34" charset="-120"/>
+              </a:rPr>
+              <a:t>Physician</a:t>
+            </a:r>
+            <a:endParaRPr lang="en-US" sz="1000" dirty="0"/>
+          </a:p>
+          <a:p>
+            <a:pPr algn="ctr" indent="0" marL="0">
+              <a:buNone/>
+            </a:pPr>
+            <a:r>
+              <a:rPr lang="en-US" sz="1000" b="1" dirty="0">
+                <a:solidFill>
+                  <a:srgbClr val="2DD4BF"/>
+                </a:solidFill>
+                <a:latin typeface="Trebuchet MS" pitchFamily="34" charset="0"/>
+                <a:ea typeface="Trebuchet MS" pitchFamily="34" charset="-122"/>
+                <a:cs typeface="Trebuchet MS" pitchFamily="34" charset="-120"/>
+              </a:rPr>
+              <a:t>Labs</a:t>
+            </a:r>
+            <a:endParaRPr lang="en-US" sz="1000" dirty="0"/>
+          </a:p>
+        </p:txBody>
+      </p:sp>
+      <p:sp>
+        <p:nvSpPr>
+          <p:cNvPr id="12" name="Text 10"/>
+          <p:cNvSpPr/>
+          <p:nvPr/>
+        </p:nvSpPr>
+        <p:spPr>
+          <a:xfrm>
+            <a:off x="521208" y="1783080"/>
+            <a:ext cx="2606040" cy="530352"/>
+          </a:xfrm>
+          <a:prstGeom prst="rect">
+            <a:avLst/>
+          </a:prstGeom>
+          <a:noFill/>
+          <a:ln/>
+        </p:spPr>
+        <p:txBody>
+          <a:bodyPr wrap="square" lIns="0" tIns="0" rIns="0" bIns="0" rtlCol="0" anchor="ctr"/>
+          <a:lstStyle/>
+          <a:p>
+            <a:pPr indent="0" marL="0">
+              <a:buNone/>
+            </a:pPr>
+            <a:r>
+              <a:rPr lang="en-US" sz="1000" dirty="0">
+                <a:solidFill>
+                  <a:srgbClr val="FFFFFF"/>
+                </a:solidFill>
+                <a:latin typeface="Calibri" pitchFamily="34" charset="0"/>
+                <a:ea typeface="Calibri" pitchFamily="34" charset="-122"/>
+                <a:cs typeface="Calibri" pitchFamily="34" charset="-120"/>
+              </a:rPr>
+              <a:t>AI-native forward-looking financial intelligence</a:t>
+            </a:r>
+            <a:endParaRPr lang="en-US" sz="1000" dirty="0"/>
+          </a:p>
+        </p:txBody>
+      </p:sp>
+      <p:sp>
+        <p:nvSpPr>
+          <p:cNvPr id="13" name="Text 11"/>
+          <p:cNvSpPr/>
+          <p:nvPr/>
+        </p:nvSpPr>
+        <p:spPr>
+          <a:xfrm>
+            <a:off x="3200400" y="1783080"/>
+            <a:ext cx="713232" cy="530352"/>
+          </a:xfrm>
+          <a:prstGeom prst="rect">
+            <a:avLst/>
+          </a:prstGeom>
+          <a:noFill/>
+          <a:ln/>
+        </p:spPr>
+        <p:txBody>
+          <a:bodyPr wrap="square" lIns="0" tIns="0" rIns="0" bIns="0" rtlCol="0" anchor="ctr"/>
+          <a:lstStyle/>
+          <a:p>
+            <a:pPr algn="ctr" indent="0" marL="0">
+              <a:buNone/>
+            </a:pPr>
+            <a:r>
+              <a:rPr lang="en-US" sz="1100" dirty="0">
+                <a:solidFill>
+                  <a:srgbClr val="4A5A72"/>
+                </a:solidFill>
+                <a:latin typeface="Trebuchet MS" pitchFamily="34" charset="0"/>
+                <a:ea typeface="Trebuchet MS" pitchFamily="34" charset="-122"/>
+                <a:cs typeface="Trebuchet MS" pitchFamily="34" charset="-120"/>
+              </a:rPr>
+              <a:t>✕</a:t>
+            </a:r>
+            <a:endParaRPr lang="en-US" sz="1100" dirty="0"/>
+          </a:p>
+        </p:txBody>
+      </p:sp>
+      <p:sp>
+        <p:nvSpPr>
+          <p:cNvPr id="14" name="Text 12"/>
+          <p:cNvSpPr/>
+          <p:nvPr/>
+        </p:nvSpPr>
+        <p:spPr>
+          <a:xfrm>
+            <a:off x="3913632" y="1783080"/>
+            <a:ext cx="713232" cy="530352"/>
+          </a:xfrm>
+          <a:prstGeom prst="rect">
+            <a:avLst/>
+          </a:prstGeom>
+          <a:noFill/>
+          <a:ln/>
+        </p:spPr>
+        <p:txBody>
+          <a:bodyPr wrap="square" lIns="0" tIns="0" rIns="0" bIns="0" rtlCol="0" anchor="ctr"/>
+          <a:lstStyle/>
+          <a:p>
+            <a:pPr algn="ctr" indent="0" marL="0">
+              <a:buNone/>
+            </a:pPr>
+            <a:r>
+              <a:rPr lang="en-US" sz="1400" b="1" dirty="0">
+                <a:solidFill>
+                  <a:srgbClr val="FBBF24"/>
+                </a:solidFill>
+                <a:latin typeface="Trebuchet MS" pitchFamily="34" charset="0"/>
+                <a:ea typeface="Trebuchet MS" pitchFamily="34" charset="-122"/>
+                <a:cs typeface="Trebuchet MS" pitchFamily="34" charset="-120"/>
+              </a:rPr>
+              <a:t>~</a:t>
+            </a:r>
+            <a:endParaRPr lang="en-US" sz="1400" dirty="0"/>
+          </a:p>
+        </p:txBody>
+      </p:sp>
+      <p:sp>
+        <p:nvSpPr>
+          <p:cNvPr id="15" name="Text 13"/>
+          <p:cNvSpPr/>
+          <p:nvPr/>
+        </p:nvSpPr>
+        <p:spPr>
+          <a:xfrm>
+            <a:off x="4626864" y="1783080"/>
+            <a:ext cx="713232" cy="530352"/>
+          </a:xfrm>
+          <a:prstGeom prst="rect">
+            <a:avLst/>
+          </a:prstGeom>
+          <a:noFill/>
+          <a:ln/>
+        </p:spPr>
+        <p:txBody>
+          <a:bodyPr wrap="square" lIns="0" tIns="0" rIns="0" bIns="0" rtlCol="0" anchor="ctr"/>
+          <a:lstStyle/>
+          <a:p>
+            <a:pPr algn="ctr" indent="0" marL="0">
+              <a:buNone/>
+            </a:pPr>
+            <a:r>
+              <a:rPr lang="en-US" sz="1100" dirty="0">
+                <a:solidFill>
+                  <a:srgbClr val="4A5A72"/>
+                </a:solidFill>
+                <a:latin typeface="Trebuchet MS" pitchFamily="34" charset="0"/>
+                <a:ea typeface="Trebuchet MS" pitchFamily="34" charset="-122"/>
+                <a:cs typeface="Trebuchet MS" pitchFamily="34" charset="-120"/>
+              </a:rPr>
+              <a:t>✕</a:t>
+            </a:r>
+            <a:endParaRPr lang="en-US" sz="1100" dirty="0"/>
+          </a:p>
+        </p:txBody>
+      </p:sp>
+      <p:sp>
+        <p:nvSpPr>
+          <p:cNvPr id="16" name="Text 14"/>
+          <p:cNvSpPr/>
+          <p:nvPr/>
+        </p:nvSpPr>
+        <p:spPr>
+          <a:xfrm>
+            <a:off x="5340096" y="1783080"/>
+            <a:ext cx="713232" cy="530352"/>
+          </a:xfrm>
+          <a:prstGeom prst="rect">
+            <a:avLst/>
+          </a:prstGeom>
+          <a:noFill/>
+          <a:ln/>
+        </p:spPr>
+        <p:txBody>
+          <a:bodyPr wrap="square" lIns="0" tIns="0" rIns="0" bIns="0" rtlCol="0" anchor="ctr"/>
+          <a:lstStyle/>
+          <a:p>
+            <a:pPr algn="ctr" indent="0" marL="0">
+              <a:buNone/>
+            </a:pPr>
+            <a:r>
+              <a:rPr lang="en-US" sz="1100" dirty="0">
+                <a:solidFill>
+                  <a:srgbClr val="4A5A72"/>
+                </a:solidFill>
+                <a:latin typeface="Trebuchet MS" pitchFamily="34" charset="0"/>
+                <a:ea typeface="Trebuchet MS" pitchFamily="34" charset="-122"/>
+                <a:cs typeface="Trebuchet MS" pitchFamily="34" charset="-120"/>
+              </a:rPr>
+              <a:t>✕</a:t>
+            </a:r>
+            <a:endParaRPr lang="en-US" sz="1100" dirty="0"/>
+          </a:p>
+        </p:txBody>
+      </p:sp>
+      <p:sp>
+        <p:nvSpPr>
+          <p:cNvPr id="17" name="Text 15"/>
+          <p:cNvSpPr/>
+          <p:nvPr/>
+        </p:nvSpPr>
+        <p:spPr>
+          <a:xfrm>
+            <a:off x="6053328" y="1783080"/>
+            <a:ext cx="713232" cy="530352"/>
+          </a:xfrm>
+          <a:prstGeom prst="rect">
+            <a:avLst/>
+          </a:prstGeom>
+          <a:noFill/>
+          <a:ln/>
+        </p:spPr>
+        <p:txBody>
+          <a:bodyPr wrap="square" lIns="0" tIns="0" rIns="0" bIns="0" rtlCol="0" anchor="ctr"/>
+          <a:lstStyle/>
+          <a:p>
+            <a:pPr algn="ctr" indent="0" marL="0">
+              <a:buNone/>
+            </a:pPr>
+            <a:r>
+              <a:rPr lang="en-US" sz="1400" b="1" dirty="0">
+                <a:solidFill>
+                  <a:srgbClr val="FBBF24"/>
+                </a:solidFill>
+                <a:latin typeface="Trebuchet MS" pitchFamily="34" charset="0"/>
+                <a:ea typeface="Trebuchet MS" pitchFamily="34" charset="-122"/>
+                <a:cs typeface="Trebuchet MS" pitchFamily="34" charset="-120"/>
+              </a:rPr>
+              <a:t>~</a:t>
+            </a:r>
+            <a:endParaRPr lang="en-US" sz="1400" dirty="0"/>
+          </a:p>
+        </p:txBody>
+      </p:sp>
+      <p:sp>
+        <p:nvSpPr>
+          <p:cNvPr id="18" name="Text 16"/>
+          <p:cNvSpPr/>
+          <p:nvPr/>
+        </p:nvSpPr>
+        <p:spPr>
+          <a:xfrm>
+            <a:off x="6766560" y="1783080"/>
+            <a:ext cx="713232" cy="530352"/>
+          </a:xfrm>
+          <a:prstGeom prst="rect">
+            <a:avLst/>
+          </a:prstGeom>
+          <a:noFill/>
+          <a:ln/>
+        </p:spPr>
+        <p:txBody>
+          <a:bodyPr wrap="square" lIns="0" tIns="0" rIns="0" bIns="0" rtlCol="0" anchor="ctr"/>
+          <a:lstStyle/>
+          <a:p>
+            <a:pPr algn="ctr" indent="0" marL="0">
+              <a:buNone/>
+            </a:pPr>
+            <a:r>
+              <a:rPr lang="en-US" sz="1100" dirty="0">
+                <a:solidFill>
+                  <a:srgbClr val="4A5A72"/>
+                </a:solidFill>
+                <a:latin typeface="Trebuchet MS" pitchFamily="34" charset="0"/>
+                <a:ea typeface="Trebuchet MS" pitchFamily="34" charset="-122"/>
+                <a:cs typeface="Trebuchet MS" pitchFamily="34" charset="-120"/>
+              </a:rPr>
+              <a:t>✕</a:t>
+            </a:r>
+            <a:endParaRPr lang="en-US" sz="1100" dirty="0"/>
+          </a:p>
+        </p:txBody>
+      </p:sp>
+      <p:sp>
+        <p:nvSpPr>
+          <p:cNvPr id="19" name="Text 17"/>
+          <p:cNvSpPr/>
+          <p:nvPr/>
+        </p:nvSpPr>
+        <p:spPr>
+          <a:xfrm>
+            <a:off x="7479792" y="1783080"/>
+            <a:ext cx="960120" cy="530352"/>
+          </a:xfrm>
+          <a:prstGeom prst="rect">
+            <a:avLst/>
+          </a:prstGeom>
+          <a:noFill/>
+          <a:ln/>
+        </p:spPr>
+        <p:txBody>
+          <a:bodyPr wrap="square" lIns="0" tIns="0" rIns="0" bIns="0" rtlCol="0" anchor="ctr"/>
+          <a:lstStyle/>
+          <a:p>
+            <a:pPr algn="ctr" indent="0" marL="0">
+              <a:buNone/>
+            </a:pPr>
+            <a:r>
+              <a:rPr lang="en-US" sz="1500" b="1" dirty="0">
+                <a:solidFill>
+                  <a:srgbClr val="5EEAD4"/>
+                </a:solidFill>
+                <a:latin typeface="Trebuchet MS" pitchFamily="34" charset="0"/>
+                <a:ea typeface="Trebuchet MS" pitchFamily="34" charset="-122"/>
+                <a:cs typeface="Trebuchet MS" pitchFamily="34" charset="-120"/>
+              </a:rPr>
+              <a:t>✓</a:t>
+            </a:r>
+            <a:endParaRPr lang="en-US" sz="1500" dirty="0"/>
+          </a:p>
+        </p:txBody>
+      </p:sp>
+      <p:sp>
+        <p:nvSpPr>
+          <p:cNvPr id="20" name="Shape 18"/>
+          <p:cNvSpPr/>
+          <p:nvPr/>
+        </p:nvSpPr>
+        <p:spPr>
+          <a:xfrm>
+            <a:off x="411480" y="2313432"/>
+            <a:ext cx="7068312" cy="530352"/>
+          </a:xfrm>
+          <a:prstGeom prst="rect">
+            <a:avLst/>
+          </a:prstGeom>
+          <a:solidFill>
+            <a:srgbClr val="16213A"/>
+          </a:solidFill>
+          <a:ln/>
+        </p:spPr>
+      </p:sp>
+      <p:sp>
+        <p:nvSpPr>
+          <p:cNvPr id="21" name="Text 19"/>
+          <p:cNvSpPr/>
+          <p:nvPr/>
+        </p:nvSpPr>
+        <p:spPr>
+          <a:xfrm>
+            <a:off x="521208" y="2313432"/>
+            <a:ext cx="2606040" cy="530352"/>
+          </a:xfrm>
+          <a:prstGeom prst="rect">
+            <a:avLst/>
+          </a:prstGeom>
+          <a:noFill/>
+          <a:ln/>
+        </p:spPr>
+        <p:txBody>
+          <a:bodyPr wrap="square" lIns="0" tIns="0" rIns="0" bIns="0" rtlCol="0" anchor="ctr"/>
+          <a:lstStyle/>
+          <a:p>
+            <a:pPr indent="0" marL="0">
+              <a:buNone/>
+            </a:pPr>
+            <a:r>
+              <a:rPr lang="en-US" sz="1000" dirty="0">
+                <a:solidFill>
+                  <a:srgbClr val="FFFFFF"/>
+                </a:solidFill>
+                <a:latin typeface="Calibri" pitchFamily="34" charset="0"/>
+                <a:ea typeface="Calibri" pitchFamily="34" charset="-122"/>
+                <a:cs typeface="Calibri" pitchFamily="34" charset="-120"/>
+              </a:rPr>
+              <a:t>No migration (layers on existing tools)</a:t>
+            </a:r>
+            <a:endParaRPr lang="en-US" sz="1000" dirty="0"/>
+          </a:p>
+        </p:txBody>
+      </p:sp>
+      <p:sp>
+        <p:nvSpPr>
+          <p:cNvPr id="22" name="Text 20"/>
+          <p:cNvSpPr/>
+          <p:nvPr/>
+        </p:nvSpPr>
+        <p:spPr>
+          <a:xfrm>
+            <a:off x="3200400" y="2313432"/>
+            <a:ext cx="713232" cy="530352"/>
+          </a:xfrm>
+          <a:prstGeom prst="rect">
+            <a:avLst/>
+          </a:prstGeom>
+          <a:noFill/>
+          <a:ln/>
+        </p:spPr>
+        <p:txBody>
+          <a:bodyPr wrap="square" lIns="0" tIns="0" rIns="0" bIns="0" rtlCol="0" anchor="ctr"/>
+          <a:lstStyle/>
+          <a:p>
+            <a:pPr algn="ctr" indent="0" marL="0">
+              <a:buNone/>
+            </a:pPr>
+            <a:r>
+              <a:rPr lang="en-US" sz="1100" dirty="0">
+                <a:solidFill>
+                  <a:srgbClr val="4A5A72"/>
+                </a:solidFill>
+                <a:latin typeface="Trebuchet MS" pitchFamily="34" charset="0"/>
+                <a:ea typeface="Trebuchet MS" pitchFamily="34" charset="-122"/>
+                <a:cs typeface="Trebuchet MS" pitchFamily="34" charset="-120"/>
+              </a:rPr>
+              <a:t>✕</a:t>
+            </a:r>
+            <a:endParaRPr lang="en-US" sz="1100" dirty="0"/>
+          </a:p>
+        </p:txBody>
+      </p:sp>
+      <p:sp>
+        <p:nvSpPr>
+          <p:cNvPr id="23" name="Text 21"/>
+          <p:cNvSpPr/>
+          <p:nvPr/>
+        </p:nvSpPr>
+        <p:spPr>
+          <a:xfrm>
+            <a:off x="3913632" y="2313432"/>
+            <a:ext cx="713232" cy="530352"/>
+          </a:xfrm>
+          <a:prstGeom prst="rect">
+            <a:avLst/>
+          </a:prstGeom>
+          <a:noFill/>
+          <a:ln/>
+        </p:spPr>
+        <p:txBody>
+          <a:bodyPr wrap="square" lIns="0" tIns="0" rIns="0" bIns="0" rtlCol="0" anchor="ctr"/>
+          <a:lstStyle/>
+          <a:p>
+            <a:pPr algn="ctr" indent="0" marL="0">
+              <a:buNone/>
+            </a:pPr>
+            <a:r>
+              <a:rPr lang="en-US" sz="1100" dirty="0">
+                <a:solidFill>
+                  <a:srgbClr val="4A5A72"/>
+                </a:solidFill>
+                <a:latin typeface="Trebuchet MS" pitchFamily="34" charset="0"/>
+                <a:ea typeface="Trebuchet MS" pitchFamily="34" charset="-122"/>
+                <a:cs typeface="Trebuchet MS" pitchFamily="34" charset="-120"/>
+              </a:rPr>
+              <a:t>✕</a:t>
+            </a:r>
+            <a:endParaRPr lang="en-US" sz="1100" dirty="0"/>
+          </a:p>
+        </p:txBody>
+      </p:sp>
+      <p:sp>
+        <p:nvSpPr>
+          <p:cNvPr id="24" name="Text 22"/>
+          <p:cNvSpPr/>
+          <p:nvPr/>
+        </p:nvSpPr>
+        <p:spPr>
+          <a:xfrm>
+            <a:off x="4626864" y="2313432"/>
+            <a:ext cx="713232" cy="530352"/>
+          </a:xfrm>
+          <a:prstGeom prst="rect">
+            <a:avLst/>
+          </a:prstGeom>
+          <a:noFill/>
+          <a:ln/>
+        </p:spPr>
+        <p:txBody>
+          <a:bodyPr wrap="square" lIns="0" tIns="0" rIns="0" bIns="0" rtlCol="0" anchor="ctr"/>
+          <a:lstStyle/>
+          <a:p>
+            <a:pPr algn="ctr" indent="0" marL="0">
+              <a:buNone/>
+            </a:pPr>
+            <a:r>
+              <a:rPr lang="en-US" sz="1100" dirty="0">
+                <a:solidFill>
+                  <a:srgbClr val="4A5A72"/>
+                </a:solidFill>
+                <a:latin typeface="Trebuchet MS" pitchFamily="34" charset="0"/>
+                <a:ea typeface="Trebuchet MS" pitchFamily="34" charset="-122"/>
+                <a:cs typeface="Trebuchet MS" pitchFamily="34" charset="-120"/>
+              </a:rPr>
+              <a:t>✕</a:t>
+            </a:r>
+            <a:endParaRPr lang="en-US" sz="1100" dirty="0"/>
+          </a:p>
+        </p:txBody>
+      </p:sp>
+      <p:sp>
+        <p:nvSpPr>
+          <p:cNvPr id="25" name="Text 23"/>
+          <p:cNvSpPr/>
+          <p:nvPr/>
+        </p:nvSpPr>
+        <p:spPr>
+          <a:xfrm>
+            <a:off x="5340096" y="2313432"/>
+            <a:ext cx="713232" cy="530352"/>
+          </a:xfrm>
+          <a:prstGeom prst="rect">
+            <a:avLst/>
+          </a:prstGeom>
+          <a:noFill/>
+          <a:ln/>
+        </p:spPr>
+        <p:txBody>
+          <a:bodyPr wrap="square" lIns="0" tIns="0" rIns="0" bIns="0" rtlCol="0" anchor="ctr"/>
+          <a:lstStyle/>
+          <a:p>
+            <a:pPr algn="ctr" indent="0" marL="0">
+              <a:buNone/>
+            </a:pPr>
+            <a:r>
+              <a:rPr lang="en-US" sz="1100" dirty="0">
+                <a:solidFill>
+                  <a:srgbClr val="4A5A72"/>
+                </a:solidFill>
+                <a:latin typeface="Trebuchet MS" pitchFamily="34" charset="0"/>
+                <a:ea typeface="Trebuchet MS" pitchFamily="34" charset="-122"/>
+                <a:cs typeface="Trebuchet MS" pitchFamily="34" charset="-120"/>
+              </a:rPr>
+              <a:t>✕</a:t>
+            </a:r>
+            <a:endParaRPr lang="en-US" sz="1100" dirty="0"/>
+          </a:p>
+        </p:txBody>
+      </p:sp>
+      <p:sp>
+        <p:nvSpPr>
+          <p:cNvPr id="26" name="Text 24"/>
+          <p:cNvSpPr/>
+          <p:nvPr/>
+        </p:nvSpPr>
+        <p:spPr>
+          <a:xfrm>
+            <a:off x="6053328" y="2313432"/>
+            <a:ext cx="713232" cy="530352"/>
+          </a:xfrm>
+          <a:prstGeom prst="rect">
+            <a:avLst/>
+          </a:prstGeom>
+          <a:noFill/>
+          <a:ln/>
+        </p:spPr>
+        <p:txBody>
+          <a:bodyPr wrap="square" lIns="0" tIns="0" rIns="0" bIns="0" rtlCol="0" anchor="ctr"/>
+          <a:lstStyle/>
+          <a:p>
+            <a:pPr algn="ctr" indent="0" marL="0">
+              <a:buNone/>
+            </a:pPr>
+            <a:r>
+              <a:rPr lang="en-US" sz="1400" b="1" dirty="0">
+                <a:solidFill>
+                  <a:srgbClr val="FBBF24"/>
+                </a:solidFill>
+                <a:latin typeface="Trebuchet MS" pitchFamily="34" charset="0"/>
+                <a:ea typeface="Trebuchet MS" pitchFamily="34" charset="-122"/>
+                <a:cs typeface="Trebuchet MS" pitchFamily="34" charset="-120"/>
+              </a:rPr>
+              <a:t>~</a:t>
+            </a:r>
+            <a:endParaRPr lang="en-US" sz="1400" dirty="0"/>
+          </a:p>
+        </p:txBody>
+      </p:sp>
+      <p:sp>
+        <p:nvSpPr>
+          <p:cNvPr id="27" name="Text 25"/>
+          <p:cNvSpPr/>
+          <p:nvPr/>
+        </p:nvSpPr>
+        <p:spPr>
+          <a:xfrm>
+            <a:off x="6766560" y="2313432"/>
+            <a:ext cx="713232" cy="530352"/>
+          </a:xfrm>
+          <a:prstGeom prst="rect">
+            <a:avLst/>
+          </a:prstGeom>
+          <a:noFill/>
+          <a:ln/>
+        </p:spPr>
+        <p:txBody>
+          <a:bodyPr wrap="square" lIns="0" tIns="0" rIns="0" bIns="0" rtlCol="0" anchor="ctr"/>
+          <a:lstStyle/>
+          <a:p>
+            <a:pPr algn="ctr" indent="0" marL="0">
+              <a:buNone/>
+            </a:pPr>
+            <a:r>
+              <a:rPr lang="en-US" sz="1100" dirty="0">
+                <a:solidFill>
+                  <a:srgbClr val="4A5A72"/>
+                </a:solidFill>
+                <a:latin typeface="Trebuchet MS" pitchFamily="34" charset="0"/>
+                <a:ea typeface="Trebuchet MS" pitchFamily="34" charset="-122"/>
+                <a:cs typeface="Trebuchet MS" pitchFamily="34" charset="-120"/>
+              </a:rPr>
+              <a:t>✕</a:t>
+            </a:r>
+            <a:endParaRPr lang="en-US" sz="1100" dirty="0"/>
+          </a:p>
+        </p:txBody>
+      </p:sp>
+      <p:sp>
+        <p:nvSpPr>
+          <p:cNvPr id="28" name="Text 26"/>
+          <p:cNvSpPr/>
+          <p:nvPr/>
+        </p:nvSpPr>
+        <p:spPr>
+          <a:xfrm>
+            <a:off x="7479792" y="2313432"/>
+            <a:ext cx="960120" cy="530352"/>
+          </a:xfrm>
+          <a:prstGeom prst="rect">
+            <a:avLst/>
+          </a:prstGeom>
+          <a:noFill/>
+          <a:ln/>
+        </p:spPr>
+        <p:txBody>
+          <a:bodyPr wrap="square" lIns="0" tIns="0" rIns="0" bIns="0" rtlCol="0" anchor="ctr"/>
+          <a:lstStyle/>
+          <a:p>
+            <a:pPr algn="ctr" indent="0" marL="0">
+              <a:buNone/>
+            </a:pPr>
+            <a:r>
+              <a:rPr lang="en-US" sz="1500" b="1" dirty="0">
+                <a:solidFill>
+                  <a:srgbClr val="5EEAD4"/>
+                </a:solidFill>
+                <a:latin typeface="Trebuchet MS" pitchFamily="34" charset="0"/>
+                <a:ea typeface="Trebuchet MS" pitchFamily="34" charset="-122"/>
+                <a:cs typeface="Trebuchet MS" pitchFamily="34" charset="-120"/>
+              </a:rPr>
+              <a:t>✓</a:t>
+            </a:r>
+            <a:endParaRPr lang="en-US" sz="1500" dirty="0"/>
+          </a:p>
+        </p:txBody>
+      </p:sp>
+      <p:sp>
+        <p:nvSpPr>
+          <p:cNvPr id="29" name="Text 27"/>
+          <p:cNvSpPr/>
+          <p:nvPr/>
+        </p:nvSpPr>
+        <p:spPr>
+          <a:xfrm>
+            <a:off x="521208" y="2843784"/>
+            <a:ext cx="2606040" cy="530352"/>
+          </a:xfrm>
+          <a:prstGeom prst="rect">
+            <a:avLst/>
+          </a:prstGeom>
+          <a:noFill/>
+          <a:ln/>
+        </p:spPr>
+        <p:txBody>
+          <a:bodyPr wrap="square" lIns="0" tIns="0" rIns="0" bIns="0" rtlCol="0" anchor="ctr"/>
+          <a:lstStyle/>
+          <a:p>
+            <a:pPr indent="0" marL="0">
+              <a:buNone/>
+            </a:pPr>
+            <a:r>
+              <a:rPr lang="en-US" sz="1000" dirty="0">
+                <a:solidFill>
+                  <a:srgbClr val="FFFFFF"/>
+                </a:solidFill>
+                <a:latin typeface="Calibri" pitchFamily="34" charset="0"/>
+                <a:ea typeface="Calibri" pitchFamily="34" charset="-122"/>
+                <a:cs typeface="Calibri" pitchFamily="34" charset="-120"/>
+              </a:rPr>
+              <a:t>Built for the just-launched / first-year clinic</a:t>
+            </a:r>
+            <a:endParaRPr lang="en-US" sz="1000" dirty="0"/>
+          </a:p>
+        </p:txBody>
+      </p:sp>
+      <p:sp>
+        <p:nvSpPr>
+          <p:cNvPr id="30" name="Text 28"/>
+          <p:cNvSpPr/>
+          <p:nvPr/>
+        </p:nvSpPr>
+        <p:spPr>
+          <a:xfrm>
+            <a:off x="3200400" y="2843784"/>
+            <a:ext cx="713232" cy="530352"/>
+          </a:xfrm>
+          <a:prstGeom prst="rect">
+            <a:avLst/>
+          </a:prstGeom>
+          <a:noFill/>
+          <a:ln/>
+        </p:spPr>
+        <p:txBody>
+          <a:bodyPr wrap="square" lIns="0" tIns="0" rIns="0" bIns="0" rtlCol="0" anchor="ctr"/>
+          <a:lstStyle/>
+          <a:p>
+            <a:pPr algn="ctr" indent="0" marL="0">
+              <a:buNone/>
+            </a:pPr>
+            <a:r>
+              <a:rPr lang="en-US" sz="1100" dirty="0">
+                <a:solidFill>
+                  <a:srgbClr val="4A5A72"/>
+                </a:solidFill>
+                <a:latin typeface="Trebuchet MS" pitchFamily="34" charset="0"/>
+                <a:ea typeface="Trebuchet MS" pitchFamily="34" charset="-122"/>
+                <a:cs typeface="Trebuchet MS" pitchFamily="34" charset="-120"/>
+              </a:rPr>
+              <a:t>✕</a:t>
+            </a:r>
+            <a:endParaRPr lang="en-US" sz="1100" dirty="0"/>
+          </a:p>
+        </p:txBody>
+      </p:sp>
+      <p:sp>
+        <p:nvSpPr>
+          <p:cNvPr id="31" name="Text 29"/>
+          <p:cNvSpPr/>
+          <p:nvPr/>
+        </p:nvSpPr>
+        <p:spPr>
+          <a:xfrm>
+            <a:off x="3913632" y="2843784"/>
+            <a:ext cx="713232" cy="530352"/>
+          </a:xfrm>
+          <a:prstGeom prst="rect">
+            <a:avLst/>
+          </a:prstGeom>
+          <a:noFill/>
+          <a:ln/>
+        </p:spPr>
+        <p:txBody>
+          <a:bodyPr wrap="square" lIns="0" tIns="0" rIns="0" bIns="0" rtlCol="0" anchor="ctr"/>
+          <a:lstStyle/>
+          <a:p>
+            <a:pPr algn="ctr" indent="0" marL="0">
+              <a:buNone/>
+            </a:pPr>
+            <a:r>
+              <a:rPr lang="en-US" sz="1100" dirty="0">
+                <a:solidFill>
+                  <a:srgbClr val="4A5A72"/>
+                </a:solidFill>
+                <a:latin typeface="Trebuchet MS" pitchFamily="34" charset="0"/>
+                <a:ea typeface="Trebuchet MS" pitchFamily="34" charset="-122"/>
+                <a:cs typeface="Trebuchet MS" pitchFamily="34" charset="-120"/>
+              </a:rPr>
+              <a:t>✕</a:t>
+            </a:r>
+            <a:endParaRPr lang="en-US" sz="1100" dirty="0"/>
+          </a:p>
+        </p:txBody>
+      </p:sp>
+      <p:sp>
+        <p:nvSpPr>
+          <p:cNvPr id="32" name="Text 30"/>
+          <p:cNvSpPr/>
+          <p:nvPr/>
+        </p:nvSpPr>
+        <p:spPr>
+          <a:xfrm>
+            <a:off x="4626864" y="2843784"/>
+            <a:ext cx="713232" cy="530352"/>
+          </a:xfrm>
+          <a:prstGeom prst="rect">
+            <a:avLst/>
+          </a:prstGeom>
+          <a:noFill/>
+          <a:ln/>
+        </p:spPr>
+        <p:txBody>
+          <a:bodyPr wrap="square" lIns="0" tIns="0" rIns="0" bIns="0" rtlCol="0" anchor="ctr"/>
+          <a:lstStyle/>
+          <a:p>
+            <a:pPr algn="ctr" indent="0" marL="0">
+              <a:buNone/>
+            </a:pPr>
+            <a:r>
+              <a:rPr lang="en-US" sz="1100" dirty="0">
+                <a:solidFill>
+                  <a:srgbClr val="4A5A72"/>
+                </a:solidFill>
+                <a:latin typeface="Trebuchet MS" pitchFamily="34" charset="0"/>
+                <a:ea typeface="Trebuchet MS" pitchFamily="34" charset="-122"/>
+                <a:cs typeface="Trebuchet MS" pitchFamily="34" charset="-120"/>
+              </a:rPr>
+              <a:t>✕</a:t>
+            </a:r>
+            <a:endParaRPr lang="en-US" sz="1100" dirty="0"/>
+          </a:p>
+        </p:txBody>
+      </p:sp>
+      <p:sp>
+        <p:nvSpPr>
+          <p:cNvPr id="33" name="Text 31"/>
+          <p:cNvSpPr/>
+          <p:nvPr/>
+        </p:nvSpPr>
+        <p:spPr>
+          <a:xfrm>
+            <a:off x="5340096" y="2843784"/>
+            <a:ext cx="713232" cy="530352"/>
+          </a:xfrm>
+          <a:prstGeom prst="rect">
+            <a:avLst/>
+          </a:prstGeom>
+          <a:noFill/>
+          <a:ln/>
+        </p:spPr>
+        <p:txBody>
+          <a:bodyPr wrap="square" lIns="0" tIns="0" rIns="0" bIns="0" rtlCol="0" anchor="ctr"/>
+          <a:lstStyle/>
+          <a:p>
+            <a:pPr algn="ctr" indent="0" marL="0">
+              <a:buNone/>
+            </a:pPr>
+            <a:r>
+              <a:rPr lang="en-US" sz="1100" dirty="0">
+                <a:solidFill>
+                  <a:srgbClr val="4A5A72"/>
+                </a:solidFill>
+                <a:latin typeface="Trebuchet MS" pitchFamily="34" charset="0"/>
+                <a:ea typeface="Trebuchet MS" pitchFamily="34" charset="-122"/>
+                <a:cs typeface="Trebuchet MS" pitchFamily="34" charset="-120"/>
+              </a:rPr>
+              <a:t>✕</a:t>
+            </a:r>
+            <a:endParaRPr lang="en-US" sz="1100" dirty="0"/>
+          </a:p>
+        </p:txBody>
+      </p:sp>
+      <p:sp>
+        <p:nvSpPr>
+          <p:cNvPr id="34" name="Text 32"/>
+          <p:cNvSpPr/>
+          <p:nvPr/>
+        </p:nvSpPr>
+        <p:spPr>
+          <a:xfrm>
+            <a:off x="6053328" y="2843784"/>
+            <a:ext cx="713232" cy="530352"/>
+          </a:xfrm>
+          <a:prstGeom prst="rect">
+            <a:avLst/>
+          </a:prstGeom>
+          <a:noFill/>
+          <a:ln/>
+        </p:spPr>
+        <p:txBody>
+          <a:bodyPr wrap="square" lIns="0" tIns="0" rIns="0" bIns="0" rtlCol="0" anchor="ctr"/>
+          <a:lstStyle/>
+          <a:p>
+            <a:pPr algn="ctr" indent="0" marL="0">
+              <a:buNone/>
+            </a:pPr>
+            <a:r>
+              <a:rPr lang="en-US" sz="1100" dirty="0">
+                <a:solidFill>
+                  <a:srgbClr val="4A5A72"/>
+                </a:solidFill>
+                <a:latin typeface="Trebuchet MS" pitchFamily="34" charset="0"/>
+                <a:ea typeface="Trebuchet MS" pitchFamily="34" charset="-122"/>
+                <a:cs typeface="Trebuchet MS" pitchFamily="34" charset="-120"/>
+              </a:rPr>
+              <a:t>✕</a:t>
+            </a:r>
+            <a:endParaRPr lang="en-US" sz="1100" dirty="0"/>
+          </a:p>
+        </p:txBody>
+      </p:sp>
+      <p:sp>
+        <p:nvSpPr>
+          <p:cNvPr id="35" name="Text 33"/>
+          <p:cNvSpPr/>
+          <p:nvPr/>
+        </p:nvSpPr>
+        <p:spPr>
+          <a:xfrm>
+            <a:off x="6766560" y="2843784"/>
+            <a:ext cx="713232" cy="530352"/>
+          </a:xfrm>
+          <a:prstGeom prst="rect">
+            <a:avLst/>
+          </a:prstGeom>
+          <a:noFill/>
+          <a:ln/>
+        </p:spPr>
+        <p:txBody>
+          <a:bodyPr wrap="square" lIns="0" tIns="0" rIns="0" bIns="0" rtlCol="0" anchor="ctr"/>
+          <a:lstStyle/>
+          <a:p>
+            <a:pPr algn="ctr" indent="0" marL="0">
+              <a:buNone/>
+            </a:pPr>
+            <a:r>
+              <a:rPr lang="en-US" sz="1400" b="1" dirty="0">
+                <a:solidFill>
+                  <a:srgbClr val="FBBF24"/>
+                </a:solidFill>
+                <a:latin typeface="Trebuchet MS" pitchFamily="34" charset="0"/>
+                <a:ea typeface="Trebuchet MS" pitchFamily="34" charset="-122"/>
+                <a:cs typeface="Trebuchet MS" pitchFamily="34" charset="-120"/>
+              </a:rPr>
+              <a:t>~</a:t>
+            </a:r>
+            <a:endParaRPr lang="en-US" sz="1400" dirty="0"/>
+          </a:p>
+        </p:txBody>
+      </p:sp>
+      <p:sp>
+        <p:nvSpPr>
+          <p:cNvPr id="36" name="Text 34"/>
+          <p:cNvSpPr/>
+          <p:nvPr/>
+        </p:nvSpPr>
+        <p:spPr>
+          <a:xfrm>
+            <a:off x="7479792" y="2843784"/>
+            <a:ext cx="960120" cy="530352"/>
+          </a:xfrm>
+          <a:prstGeom prst="rect">
+            <a:avLst/>
+          </a:prstGeom>
+          <a:noFill/>
+          <a:ln/>
+        </p:spPr>
+        <p:txBody>
+          <a:bodyPr wrap="square" lIns="0" tIns="0" rIns="0" bIns="0" rtlCol="0" anchor="ctr"/>
+          <a:lstStyle/>
+          <a:p>
+            <a:pPr algn="ctr" indent="0" marL="0">
+              <a:buNone/>
+            </a:pPr>
+            <a:r>
+              <a:rPr lang="en-US" sz="1500" b="1" dirty="0">
+                <a:solidFill>
+                  <a:srgbClr val="5EEAD4"/>
+                </a:solidFill>
+                <a:latin typeface="Trebuchet MS" pitchFamily="34" charset="0"/>
+                <a:ea typeface="Trebuchet MS" pitchFamily="34" charset="-122"/>
+                <a:cs typeface="Trebuchet MS" pitchFamily="34" charset="-120"/>
+              </a:rPr>
+              <a:t>✓</a:t>
+            </a:r>
+            <a:endParaRPr lang="en-US" sz="1500" dirty="0"/>
+          </a:p>
+        </p:txBody>
+      </p:sp>
+      <p:sp>
+        <p:nvSpPr>
+          <p:cNvPr id="37" name="Shape 35"/>
+          <p:cNvSpPr/>
+          <p:nvPr/>
+        </p:nvSpPr>
+        <p:spPr>
+          <a:xfrm>
+            <a:off x="411480" y="3374136"/>
+            <a:ext cx="7068312" cy="530352"/>
+          </a:xfrm>
+          <a:prstGeom prst="rect">
+            <a:avLst/>
+          </a:prstGeom>
+          <a:solidFill>
+            <a:srgbClr val="16213A"/>
+          </a:solidFill>
+          <a:ln/>
+        </p:spPr>
+      </p:sp>
+      <p:sp>
+        <p:nvSpPr>
+          <p:cNvPr id="38" name="Text 36"/>
+          <p:cNvSpPr/>
+          <p:nvPr/>
+        </p:nvSpPr>
+        <p:spPr>
+          <a:xfrm>
+            <a:off x="521208" y="3374136"/>
+            <a:ext cx="2606040" cy="530352"/>
+          </a:xfrm>
+          <a:prstGeom prst="rect">
+            <a:avLst/>
+          </a:prstGeom>
+          <a:noFill/>
+          <a:ln/>
+        </p:spPr>
+        <p:txBody>
+          <a:bodyPr wrap="square" lIns="0" tIns="0" rIns="0" bIns="0" rtlCol="0" anchor="ctr"/>
+          <a:lstStyle/>
+          <a:p>
+            <a:pPr indent="0" marL="0">
+              <a:buNone/>
+            </a:pPr>
+            <a:r>
+              <a:rPr lang="en-US" sz="1000" dirty="0">
+                <a:solidFill>
+                  <a:srgbClr val="FFFFFF"/>
+                </a:solidFill>
+                <a:latin typeface="Calibri" pitchFamily="34" charset="0"/>
+                <a:ea typeface="Calibri" pitchFamily="34" charset="-122"/>
+                <a:cs typeface="Calibri" pitchFamily="34" charset="-120"/>
+              </a:rPr>
+              <a:t>Quantified, fast ROI (in dollars)</a:t>
+            </a:r>
+            <a:endParaRPr lang="en-US" sz="1000" dirty="0"/>
+          </a:p>
+        </p:txBody>
+      </p:sp>
+      <p:sp>
+        <p:nvSpPr>
+          <p:cNvPr id="39" name="Text 37"/>
+          <p:cNvSpPr/>
+          <p:nvPr/>
+        </p:nvSpPr>
+        <p:spPr>
+          <a:xfrm>
+            <a:off x="3200400" y="3374136"/>
+            <a:ext cx="713232" cy="530352"/>
+          </a:xfrm>
+          <a:prstGeom prst="rect">
+            <a:avLst/>
+          </a:prstGeom>
+          <a:noFill/>
+          <a:ln/>
+        </p:spPr>
+        <p:txBody>
+          <a:bodyPr wrap="square" lIns="0" tIns="0" rIns="0" bIns="0" rtlCol="0" anchor="ctr"/>
+          <a:lstStyle/>
+          <a:p>
+            <a:pPr algn="ctr" indent="0" marL="0">
+              <a:buNone/>
+            </a:pPr>
+            <a:r>
+              <a:rPr lang="en-US" sz="1100" dirty="0">
+                <a:solidFill>
+                  <a:srgbClr val="4A5A72"/>
+                </a:solidFill>
+                <a:latin typeface="Trebuchet MS" pitchFamily="34" charset="0"/>
+                <a:ea typeface="Trebuchet MS" pitchFamily="34" charset="-122"/>
+                <a:cs typeface="Trebuchet MS" pitchFamily="34" charset="-120"/>
+              </a:rPr>
+              <a:t>✕</a:t>
+            </a:r>
+            <a:endParaRPr lang="en-US" sz="1100" dirty="0"/>
+          </a:p>
+        </p:txBody>
+      </p:sp>
+      <p:sp>
+        <p:nvSpPr>
+          <p:cNvPr id="40" name="Text 38"/>
+          <p:cNvSpPr/>
+          <p:nvPr/>
+        </p:nvSpPr>
+        <p:spPr>
+          <a:xfrm>
+            <a:off x="3913632" y="3374136"/>
+            <a:ext cx="713232" cy="530352"/>
+          </a:xfrm>
+          <a:prstGeom prst="rect">
+            <a:avLst/>
+          </a:prstGeom>
+          <a:noFill/>
+          <a:ln/>
+        </p:spPr>
+        <p:txBody>
+          <a:bodyPr wrap="square" lIns="0" tIns="0" rIns="0" bIns="0" rtlCol="0" anchor="ctr"/>
+          <a:lstStyle/>
+          <a:p>
+            <a:pPr algn="ctr" indent="0" marL="0">
+              <a:buNone/>
+            </a:pPr>
+            <a:r>
+              <a:rPr lang="en-US" sz="1400" b="1" dirty="0">
+                <a:solidFill>
+                  <a:srgbClr val="FBBF24"/>
+                </a:solidFill>
+                <a:latin typeface="Trebuchet MS" pitchFamily="34" charset="0"/>
+                <a:ea typeface="Trebuchet MS" pitchFamily="34" charset="-122"/>
+                <a:cs typeface="Trebuchet MS" pitchFamily="34" charset="-120"/>
+              </a:rPr>
+              <a:t>~</a:t>
+            </a:r>
+            <a:endParaRPr lang="en-US" sz="1400" dirty="0"/>
+          </a:p>
+        </p:txBody>
+      </p:sp>
+      <p:sp>
+        <p:nvSpPr>
+          <p:cNvPr id="41" name="Text 39"/>
+          <p:cNvSpPr/>
+          <p:nvPr/>
+        </p:nvSpPr>
+        <p:spPr>
+          <a:xfrm>
+            <a:off x="4626864" y="3374136"/>
+            <a:ext cx="713232" cy="530352"/>
+          </a:xfrm>
+          <a:prstGeom prst="rect">
+            <a:avLst/>
+          </a:prstGeom>
+          <a:noFill/>
+          <a:ln/>
+        </p:spPr>
+        <p:txBody>
+          <a:bodyPr wrap="square" lIns="0" tIns="0" rIns="0" bIns="0" rtlCol="0" anchor="ctr"/>
+          <a:lstStyle/>
+          <a:p>
+            <a:pPr algn="ctr" indent="0" marL="0">
+              <a:buNone/>
+            </a:pPr>
+            <a:r>
+              <a:rPr lang="en-US" sz="1100" dirty="0">
+                <a:solidFill>
+                  <a:srgbClr val="4A5A72"/>
+                </a:solidFill>
+                <a:latin typeface="Trebuchet MS" pitchFamily="34" charset="0"/>
+                <a:ea typeface="Trebuchet MS" pitchFamily="34" charset="-122"/>
+                <a:cs typeface="Trebuchet MS" pitchFamily="34" charset="-120"/>
+              </a:rPr>
+              <a:t>✕</a:t>
+            </a:r>
+            <a:endParaRPr lang="en-US" sz="1100" dirty="0"/>
+          </a:p>
+        </p:txBody>
+      </p:sp>
+      <p:sp>
+        <p:nvSpPr>
+          <p:cNvPr id="42" name="Text 40"/>
+          <p:cNvSpPr/>
+          <p:nvPr/>
+        </p:nvSpPr>
+        <p:spPr>
+          <a:xfrm>
+            <a:off x="5340096" y="3374136"/>
+            <a:ext cx="713232" cy="530352"/>
+          </a:xfrm>
+          <a:prstGeom prst="rect">
+            <a:avLst/>
+          </a:prstGeom>
+          <a:noFill/>
+          <a:ln/>
+        </p:spPr>
+        <p:txBody>
+          <a:bodyPr wrap="square" lIns="0" tIns="0" rIns="0" bIns="0" rtlCol="0" anchor="ctr"/>
+          <a:lstStyle/>
+          <a:p>
+            <a:pPr algn="ctr" indent="0" marL="0">
+              <a:buNone/>
+            </a:pPr>
+            <a:r>
+              <a:rPr lang="en-US" sz="1100" dirty="0">
+                <a:solidFill>
+                  <a:srgbClr val="4A5A72"/>
+                </a:solidFill>
+                <a:latin typeface="Trebuchet MS" pitchFamily="34" charset="0"/>
+                <a:ea typeface="Trebuchet MS" pitchFamily="34" charset="-122"/>
+                <a:cs typeface="Trebuchet MS" pitchFamily="34" charset="-120"/>
+              </a:rPr>
+              <a:t>✕</a:t>
+            </a:r>
+            <a:endParaRPr lang="en-US" sz="1100" dirty="0"/>
+          </a:p>
+        </p:txBody>
+      </p:sp>
+      <p:sp>
+        <p:nvSpPr>
+          <p:cNvPr id="43" name="Text 41"/>
+          <p:cNvSpPr/>
+          <p:nvPr/>
+        </p:nvSpPr>
+        <p:spPr>
+          <a:xfrm>
+            <a:off x="6053328" y="3374136"/>
+            <a:ext cx="713232" cy="530352"/>
+          </a:xfrm>
+          <a:prstGeom prst="rect">
+            <a:avLst/>
+          </a:prstGeom>
+          <a:noFill/>
+          <a:ln/>
+        </p:spPr>
+        <p:txBody>
+          <a:bodyPr wrap="square" lIns="0" tIns="0" rIns="0" bIns="0" rtlCol="0" anchor="ctr"/>
+          <a:lstStyle/>
+          <a:p>
+            <a:pPr algn="ctr" indent="0" marL="0">
+              <a:buNone/>
+            </a:pPr>
+            <a:r>
+              <a:rPr lang="en-US" sz="1100" dirty="0">
+                <a:solidFill>
+                  <a:srgbClr val="4A5A72"/>
+                </a:solidFill>
+                <a:latin typeface="Trebuchet MS" pitchFamily="34" charset="0"/>
+                <a:ea typeface="Trebuchet MS" pitchFamily="34" charset="-122"/>
+                <a:cs typeface="Trebuchet MS" pitchFamily="34" charset="-120"/>
+              </a:rPr>
+              <a:t>✕</a:t>
+            </a:r>
+            <a:endParaRPr lang="en-US" sz="1100" dirty="0"/>
+          </a:p>
+        </p:txBody>
+      </p:sp>
+      <p:sp>
+        <p:nvSpPr>
+          <p:cNvPr id="44" name="Text 42"/>
+          <p:cNvSpPr/>
+          <p:nvPr/>
+        </p:nvSpPr>
+        <p:spPr>
+          <a:xfrm>
+            <a:off x="6766560" y="3374136"/>
+            <a:ext cx="713232" cy="530352"/>
+          </a:xfrm>
+          <a:prstGeom prst="rect">
+            <a:avLst/>
+          </a:prstGeom>
+          <a:noFill/>
+          <a:ln/>
+        </p:spPr>
+        <p:txBody>
+          <a:bodyPr wrap="square" lIns="0" tIns="0" rIns="0" bIns="0" rtlCol="0" anchor="ctr"/>
+          <a:lstStyle/>
+          <a:p>
+            <a:pPr algn="ctr" indent="0" marL="0">
+              <a:buNone/>
+            </a:pPr>
+            <a:r>
+              <a:rPr lang="en-US" sz="1100" dirty="0">
+                <a:solidFill>
+                  <a:srgbClr val="4A5A72"/>
+                </a:solidFill>
+                <a:latin typeface="Trebuchet MS" pitchFamily="34" charset="0"/>
+                <a:ea typeface="Trebuchet MS" pitchFamily="34" charset="-122"/>
+                <a:cs typeface="Trebuchet MS" pitchFamily="34" charset="-120"/>
+              </a:rPr>
+              <a:t>✕</a:t>
+            </a:r>
+            <a:endParaRPr lang="en-US" sz="1100" dirty="0"/>
+          </a:p>
+        </p:txBody>
+      </p:sp>
+      <p:sp>
+        <p:nvSpPr>
+          <p:cNvPr id="45" name="Text 43"/>
+          <p:cNvSpPr/>
+          <p:nvPr/>
+        </p:nvSpPr>
+        <p:spPr>
+          <a:xfrm>
+            <a:off x="7479792" y="3374136"/>
+            <a:ext cx="960120" cy="530352"/>
+          </a:xfrm>
+          <a:prstGeom prst="rect">
+            <a:avLst/>
+          </a:prstGeom>
+          <a:noFill/>
+          <a:ln/>
+        </p:spPr>
+        <p:txBody>
+          <a:bodyPr wrap="square" lIns="0" tIns="0" rIns="0" bIns="0" rtlCol="0" anchor="ctr"/>
+          <a:lstStyle/>
+          <a:p>
+            <a:pPr algn="ctr" indent="0" marL="0">
+              <a:buNone/>
+            </a:pPr>
+            <a:r>
+              <a:rPr lang="en-US" sz="1500" b="1" dirty="0">
+                <a:solidFill>
+                  <a:srgbClr val="5EEAD4"/>
+                </a:solidFill>
+                <a:latin typeface="Trebuchet MS" pitchFamily="34" charset="0"/>
+                <a:ea typeface="Trebuchet MS" pitchFamily="34" charset="-122"/>
+                <a:cs typeface="Trebuchet MS" pitchFamily="34" charset="-120"/>
+              </a:rPr>
+              <a:t>✓</a:t>
+            </a:r>
+            <a:endParaRPr lang="en-US" sz="1500" dirty="0"/>
+          </a:p>
+        </p:txBody>
+      </p:sp>
+      <p:sp>
+        <p:nvSpPr>
+          <p:cNvPr id="46" name="Text 44"/>
+          <p:cNvSpPr/>
+          <p:nvPr/>
+        </p:nvSpPr>
+        <p:spPr>
+          <a:xfrm>
+            <a:off x="521208" y="3904488"/>
+            <a:ext cx="2606040" cy="530352"/>
+          </a:xfrm>
+          <a:prstGeom prst="rect">
+            <a:avLst/>
+          </a:prstGeom>
+          <a:noFill/>
+          <a:ln/>
+        </p:spPr>
+        <p:txBody>
+          <a:bodyPr wrap="square" lIns="0" tIns="0" rIns="0" bIns="0" rtlCol="0" anchor="ctr"/>
+          <a:lstStyle/>
+          <a:p>
+            <a:pPr indent="0" marL="0">
+              <a:buNone/>
+            </a:pPr>
+            <a:r>
+              <a:rPr lang="en-US" sz="1000" dirty="0">
+                <a:solidFill>
+                  <a:srgbClr val="FFFFFF"/>
+                </a:solidFill>
+                <a:latin typeface="Calibri" pitchFamily="34" charset="0"/>
+                <a:ea typeface="Calibri" pitchFamily="34" charset="-122"/>
+                <a:cs typeface="Calibri" pitchFamily="34" charset="-120"/>
+              </a:rPr>
+              <a:t>Installed base / specialty depth</a:t>
+            </a:r>
+            <a:endParaRPr lang="en-US" sz="1000" dirty="0"/>
+          </a:p>
+        </p:txBody>
+      </p:sp>
+      <p:sp>
+        <p:nvSpPr>
+          <p:cNvPr id="47" name="Text 45"/>
+          <p:cNvSpPr/>
+          <p:nvPr/>
+        </p:nvSpPr>
+        <p:spPr>
+          <a:xfrm>
+            <a:off x="3200400" y="3904488"/>
+            <a:ext cx="713232" cy="530352"/>
+          </a:xfrm>
+          <a:prstGeom prst="rect">
+            <a:avLst/>
+          </a:prstGeom>
+          <a:noFill/>
+          <a:ln/>
+        </p:spPr>
+        <p:txBody>
+          <a:bodyPr wrap="square" lIns="0" tIns="0" rIns="0" bIns="0" rtlCol="0" anchor="ctr"/>
+          <a:lstStyle/>
+          <a:p>
+            <a:pPr algn="ctr" indent="0" marL="0">
+              <a:buNone/>
+            </a:pPr>
+            <a:r>
+              <a:rPr lang="en-US" sz="1500" b="1" dirty="0">
+                <a:solidFill>
+                  <a:srgbClr val="2DD4BF"/>
+                </a:solidFill>
+                <a:latin typeface="Trebuchet MS" pitchFamily="34" charset="0"/>
+                <a:ea typeface="Trebuchet MS" pitchFamily="34" charset="-122"/>
+                <a:cs typeface="Trebuchet MS" pitchFamily="34" charset="-120"/>
+              </a:rPr>
+              <a:t>✓</a:t>
+            </a:r>
+            <a:endParaRPr lang="en-US" sz="1500" dirty="0"/>
+          </a:p>
+        </p:txBody>
+      </p:sp>
+      <p:sp>
+        <p:nvSpPr>
+          <p:cNvPr id="48" name="Text 46"/>
+          <p:cNvSpPr/>
+          <p:nvPr/>
+        </p:nvSpPr>
+        <p:spPr>
+          <a:xfrm>
+            <a:off x="3913632" y="3904488"/>
+            <a:ext cx="713232" cy="530352"/>
+          </a:xfrm>
+          <a:prstGeom prst="rect">
+            <a:avLst/>
+          </a:prstGeom>
+          <a:noFill/>
+          <a:ln/>
+        </p:spPr>
+        <p:txBody>
+          <a:bodyPr wrap="square" lIns="0" tIns="0" rIns="0" bIns="0" rtlCol="0" anchor="ctr"/>
+          <a:lstStyle/>
+          <a:p>
+            <a:pPr algn="ctr" indent="0" marL="0">
+              <a:buNone/>
+            </a:pPr>
+            <a:r>
+              <a:rPr lang="en-US" sz="1500" b="1" dirty="0">
+                <a:solidFill>
+                  <a:srgbClr val="2DD4BF"/>
+                </a:solidFill>
+                <a:latin typeface="Trebuchet MS" pitchFamily="34" charset="0"/>
+                <a:ea typeface="Trebuchet MS" pitchFamily="34" charset="-122"/>
+                <a:cs typeface="Trebuchet MS" pitchFamily="34" charset="-120"/>
+              </a:rPr>
+              <a:t>✓</a:t>
+            </a:r>
+            <a:endParaRPr lang="en-US" sz="1500" dirty="0"/>
+          </a:p>
+        </p:txBody>
+      </p:sp>
+      <p:sp>
+        <p:nvSpPr>
+          <p:cNvPr id="49" name="Text 47"/>
+          <p:cNvSpPr/>
+          <p:nvPr/>
+        </p:nvSpPr>
+        <p:spPr>
+          <a:xfrm>
+            <a:off x="4626864" y="3904488"/>
+            <a:ext cx="713232" cy="530352"/>
+          </a:xfrm>
+          <a:prstGeom prst="rect">
+            <a:avLst/>
+          </a:prstGeom>
+          <a:noFill/>
+          <a:ln/>
+        </p:spPr>
+        <p:txBody>
+          <a:bodyPr wrap="square" lIns="0" tIns="0" rIns="0" bIns="0" rtlCol="0" anchor="ctr"/>
+          <a:lstStyle/>
+          <a:p>
+            <a:pPr algn="ctr" indent="0" marL="0">
+              <a:buNone/>
+            </a:pPr>
+            <a:r>
+              <a:rPr lang="en-US" sz="1500" b="1" dirty="0">
+                <a:solidFill>
+                  <a:srgbClr val="2DD4BF"/>
+                </a:solidFill>
+                <a:latin typeface="Trebuchet MS" pitchFamily="34" charset="0"/>
+                <a:ea typeface="Trebuchet MS" pitchFamily="34" charset="-122"/>
+                <a:cs typeface="Trebuchet MS" pitchFamily="34" charset="-120"/>
+              </a:rPr>
+              <a:t>✓</a:t>
+            </a:r>
+            <a:endParaRPr lang="en-US" sz="1500" dirty="0"/>
+          </a:p>
+        </p:txBody>
+      </p:sp>
+      <p:sp>
+        <p:nvSpPr>
+          <p:cNvPr id="50" name="Text 48"/>
+          <p:cNvSpPr/>
+          <p:nvPr/>
+        </p:nvSpPr>
+        <p:spPr>
+          <a:xfrm>
+            <a:off x="5340096" y="3904488"/>
+            <a:ext cx="713232" cy="530352"/>
+          </a:xfrm>
+          <a:prstGeom prst="rect">
+            <a:avLst/>
+          </a:prstGeom>
+          <a:noFill/>
+          <a:ln/>
+        </p:spPr>
+        <p:txBody>
+          <a:bodyPr wrap="square" lIns="0" tIns="0" rIns="0" bIns="0" rtlCol="0" anchor="ctr"/>
+          <a:lstStyle/>
+          <a:p>
+            <a:pPr algn="ctr" indent="0" marL="0">
+              <a:buNone/>
+            </a:pPr>
+            <a:r>
+              <a:rPr lang="en-US" sz="1500" b="1" dirty="0">
+                <a:solidFill>
+                  <a:srgbClr val="2DD4BF"/>
+                </a:solidFill>
+                <a:latin typeface="Trebuchet MS" pitchFamily="34" charset="0"/>
+                <a:ea typeface="Trebuchet MS" pitchFamily="34" charset="-122"/>
+                <a:cs typeface="Trebuchet MS" pitchFamily="34" charset="-120"/>
+              </a:rPr>
+              <a:t>✓</a:t>
+            </a:r>
+            <a:endParaRPr lang="en-US" sz="1500" dirty="0"/>
+          </a:p>
+        </p:txBody>
+      </p:sp>
+      <p:sp>
+        <p:nvSpPr>
+          <p:cNvPr id="51" name="Text 49"/>
+          <p:cNvSpPr/>
+          <p:nvPr/>
+        </p:nvSpPr>
+        <p:spPr>
+          <a:xfrm>
+            <a:off x="6053328" y="3904488"/>
+            <a:ext cx="713232" cy="530352"/>
+          </a:xfrm>
+          <a:prstGeom prst="rect">
+            <a:avLst/>
+          </a:prstGeom>
+          <a:noFill/>
+          <a:ln/>
+        </p:spPr>
+        <p:txBody>
+          <a:bodyPr wrap="square" lIns="0" tIns="0" rIns="0" bIns="0" rtlCol="0" anchor="ctr"/>
+          <a:lstStyle/>
+          <a:p>
+            <a:pPr algn="ctr" indent="0" marL="0">
+              <a:buNone/>
+            </a:pPr>
+            <a:r>
+              <a:rPr lang="en-US" sz="1100" dirty="0">
+                <a:solidFill>
+                  <a:srgbClr val="4A5A72"/>
+                </a:solidFill>
+                <a:latin typeface="Trebuchet MS" pitchFamily="34" charset="0"/>
+                <a:ea typeface="Trebuchet MS" pitchFamily="34" charset="-122"/>
+                <a:cs typeface="Trebuchet MS" pitchFamily="34" charset="-120"/>
+              </a:rPr>
+              <a:t>✕</a:t>
+            </a:r>
+            <a:endParaRPr lang="en-US" sz="1100" dirty="0"/>
+          </a:p>
+        </p:txBody>
+      </p:sp>
+      <p:sp>
+        <p:nvSpPr>
+          <p:cNvPr id="52" name="Text 50"/>
+          <p:cNvSpPr/>
+          <p:nvPr/>
+        </p:nvSpPr>
+        <p:spPr>
+          <a:xfrm>
+            <a:off x="6766560" y="3904488"/>
+            <a:ext cx="713232" cy="530352"/>
+          </a:xfrm>
+          <a:prstGeom prst="rect">
+            <a:avLst/>
+          </a:prstGeom>
+          <a:noFill/>
+          <a:ln/>
+        </p:spPr>
+        <p:txBody>
+          <a:bodyPr wrap="square" lIns="0" tIns="0" rIns="0" bIns="0" rtlCol="0" anchor="ctr"/>
+          <a:lstStyle/>
+          <a:p>
+            <a:pPr algn="ctr" indent="0" marL="0">
+              <a:buNone/>
+            </a:pPr>
+            <a:r>
+              <a:rPr lang="en-US" sz="1400" dirty="0">
+                <a:solidFill>
+                  <a:srgbClr val="4A5A72"/>
+                </a:solidFill>
+                <a:latin typeface="Trebuchet MS" pitchFamily="34" charset="0"/>
+                <a:ea typeface="Trebuchet MS" pitchFamily="34" charset="-122"/>
+                <a:cs typeface="Trebuchet MS" pitchFamily="34" charset="-120"/>
+              </a:rPr>
+              <a:t>·</a:t>
+            </a:r>
+            <a:endParaRPr lang="en-US" sz="1400" dirty="0"/>
+          </a:p>
+        </p:txBody>
+      </p:sp>
+      <p:sp>
+        <p:nvSpPr>
+          <p:cNvPr id="53" name="Text 51"/>
+          <p:cNvSpPr/>
+          <p:nvPr/>
+        </p:nvSpPr>
+        <p:spPr>
+          <a:xfrm>
+            <a:off x="7479792" y="3904488"/>
+            <a:ext cx="960120" cy="530352"/>
+          </a:xfrm>
+          <a:prstGeom prst="rect">
+            <a:avLst/>
+          </a:prstGeom>
+          <a:noFill/>
+          <a:ln/>
+        </p:spPr>
+        <p:txBody>
+          <a:bodyPr wrap="square" lIns="0" tIns="0" rIns="0" bIns="0" rtlCol="0" anchor="ctr"/>
+          <a:lstStyle/>
+          <a:p>
+            <a:pPr algn="ctr" indent="0" marL="0">
+              <a:buNone/>
+            </a:pPr>
+            <a:r>
+              <a:rPr lang="en-US" sz="1400" b="1" dirty="0">
+                <a:solidFill>
+                  <a:srgbClr val="FBBF24"/>
+                </a:solidFill>
+                <a:latin typeface="Trebuchet MS" pitchFamily="34" charset="0"/>
+                <a:ea typeface="Trebuchet MS" pitchFamily="34" charset="-122"/>
+                <a:cs typeface="Trebuchet MS" pitchFamily="34" charset="-120"/>
+              </a:rPr>
+              <a:t>~</a:t>
+            </a:r>
+            <a:endParaRPr lang="en-US" sz="1400" dirty="0"/>
+          </a:p>
+        </p:txBody>
+      </p:sp>
+      <p:sp>
+        <p:nvSpPr>
+          <p:cNvPr id="54" name="Text 52"/>
+          <p:cNvSpPr/>
+          <p:nvPr/>
+        </p:nvSpPr>
+        <p:spPr>
+          <a:xfrm>
+            <a:off x="521208" y="4544568"/>
+            <a:ext cx="5486400" cy="274320"/>
+          </a:xfrm>
+          <a:prstGeom prst="rect">
+            <a:avLst/>
+          </a:prstGeom>
+          <a:noFill/>
+          <a:ln/>
+        </p:spPr>
+        <p:txBody>
+          <a:bodyPr wrap="square" lIns="0" tIns="0" rIns="0" bIns="0" rtlCol="0" anchor="ctr"/>
+          <a:lstStyle/>
+          <a:p>
+            <a:pPr indent="0" marL="0">
+              <a:buNone/>
+            </a:pPr>
+            <a:r>
+              <a:rPr lang="en-US" sz="900" b="1" dirty="0">
+                <a:solidFill>
+                  <a:srgbClr val="2DD4BF"/>
+                </a:solidFill>
+                <a:latin typeface="Calibri" pitchFamily="34" charset="0"/>
+                <a:ea typeface="Calibri" pitchFamily="34" charset="-122"/>
+                <a:cs typeface="Calibri" pitchFamily="34" charset="-120"/>
+              </a:rPr>
+              <a:t>✓ </a:t>
+            </a:r>
+            <a:pPr indent="0" marL="0">
+              <a:buNone/>
+            </a:pPr>
+            <a:r>
+              <a:rPr lang="en-US" sz="900" dirty="0">
+                <a:solidFill>
+                  <a:srgbClr val="8FA3BF"/>
+                </a:solidFill>
+                <a:latin typeface="Calibri" pitchFamily="34" charset="0"/>
+                <a:ea typeface="Calibri" pitchFamily="34" charset="-122"/>
+                <a:cs typeface="Calibri" pitchFamily="34" charset="-120"/>
+              </a:rPr>
+              <a:t>delivers    </a:t>
+            </a:r>
+            <a:pPr indent="0" marL="0">
+              <a:buNone/>
+            </a:pPr>
+            <a:r>
+              <a:rPr lang="en-US" sz="900" b="1" dirty="0">
+                <a:solidFill>
+                  <a:srgbClr val="FBBF24"/>
+                </a:solidFill>
+                <a:latin typeface="Calibri" pitchFamily="34" charset="0"/>
+                <a:ea typeface="Calibri" pitchFamily="34" charset="-122"/>
+                <a:cs typeface="Calibri" pitchFamily="34" charset="-120"/>
+              </a:rPr>
+              <a:t>~ </a:t>
+            </a:r>
+            <a:pPr indent="0" marL="0">
+              <a:buNone/>
+            </a:pPr>
+            <a:r>
+              <a:rPr lang="en-US" sz="900" dirty="0">
+                <a:solidFill>
+                  <a:srgbClr val="8FA3BF"/>
+                </a:solidFill>
+                <a:latin typeface="Calibri" pitchFamily="34" charset="0"/>
+                <a:ea typeface="Calibri" pitchFamily="34" charset="-122"/>
+                <a:cs typeface="Calibri" pitchFamily="34" charset="-120"/>
+              </a:rPr>
+              <a:t>partial    </a:t>
+            </a:r>
+            <a:pPr indent="0" marL="0">
+              <a:buNone/>
+            </a:pPr>
+            <a:r>
+              <a:rPr lang="en-US" sz="900" dirty="0">
+                <a:solidFill>
+                  <a:srgbClr val="4A5A72"/>
+                </a:solidFill>
+                <a:latin typeface="Calibri" pitchFamily="34" charset="0"/>
+                <a:ea typeface="Calibri" pitchFamily="34" charset="-122"/>
+                <a:cs typeface="Calibri" pitchFamily="34" charset="-120"/>
+              </a:rPr>
+              <a:t>✕ </a:t>
+            </a:r>
+            <a:pPr indent="0" marL="0">
+              <a:buNone/>
+            </a:pPr>
+            <a:r>
+              <a:rPr lang="en-US" sz="900" dirty="0">
+                <a:solidFill>
+                  <a:srgbClr val="8FA3BF"/>
+                </a:solidFill>
+                <a:latin typeface="Calibri" pitchFamily="34" charset="0"/>
+                <a:ea typeface="Calibri" pitchFamily="34" charset="-122"/>
+                <a:cs typeface="Calibri" pitchFamily="34" charset="-120"/>
+              </a:rPr>
+              <a:t>no</a:t>
+            </a:r>
+            <a:endParaRPr lang="en-US" sz="900" dirty="0"/>
+          </a:p>
+        </p:txBody>
+      </p:sp>
+      <p:sp>
+        <p:nvSpPr>
+          <p:cNvPr id="55" name="Text 53"/>
+          <p:cNvSpPr/>
+          <p:nvPr/>
+        </p:nvSpPr>
+        <p:spPr>
+          <a:xfrm>
+            <a:off x="521208" y="4846320"/>
+            <a:ext cx="8229600" cy="256032"/>
+          </a:xfrm>
+          <a:prstGeom prst="rect">
+            <a:avLst/>
+          </a:prstGeom>
+          <a:noFill/>
+          <a:ln/>
+        </p:spPr>
+        <p:txBody>
+          <a:bodyPr wrap="square" lIns="0" tIns="0" rIns="0" bIns="0" rtlCol="0" anchor="ctr"/>
+          <a:lstStyle/>
+          <a:p>
+            <a:pPr indent="0" marL="0">
+              <a:buNone/>
+            </a:pPr>
+            <a:r>
+              <a:rPr lang="en-US" sz="1000" i="1" dirty="0">
+                <a:solidFill>
+                  <a:srgbClr val="5EEAD4"/>
+                </a:solidFill>
+                <a:latin typeface="Calibri" pitchFamily="34" charset="0"/>
+                <a:ea typeface="Calibri" pitchFamily="34" charset="-122"/>
+                <a:cs typeface="Calibri" pitchFamily="34" charset="-120"/>
+              </a:rPr>
+              <a:t>The bottom row is the one we don't win — yet. Their installed base is also their innovator's dilemma.</a:t>
+            </a:r>
+            <a:endParaRPr lang="en-US" sz="1000" dirty="0"/>
+          </a:p>
+        </p:txBody>
+      </p:sp>
+    </p:spTree>
+  </p:cSld>
+  <p:clrMapOvr>
+    <a:masterClrMapping/>
+  </p:clrMapOvr>
+</p:sld>
+</file>
+
 <file path=ppt/slides/slide2.xml><?xml version="1.0" encoding="utf-8"?>
 <p:sld xmlns:a="http://schemas.openxmlformats.org/drawingml/2006/main" xmlns:r="http://schemas.openxmlformats.org/officeDocument/2006/relationships" xmlns:p="http://schemas.openxmlformats.org/presentationml/2006/main">
   <p:cSld name="Slide 2">

</xml_diff>

<commit_message>
Reconcile 5-year ARR to $35M across deck and package
- Financials slide + chart, comps/ROI ($175M, 18-30x), and pitch package
  (SOM, projections, blueprint, ROI) aligned to $35M (was $28M)
- "18% of GDP" confirmed absent from deck/package (script-only line)

Co-Authored-By: Claude Opus 4.8 <noreply@anthropic.com>
</commit_message>
<xml_diff>
--- a/docs/fundraising/pitch-deck-2026-06-11-softbank-necx.pptx
+++ b/docs/fundraising/pitch-deck-2026-06-11-softbank-necx.pptx
@@ -223,7 +223,7 @@
                   <c:v>11.5</c:v>
                 </c:pt>
                 <c:pt idx="4">
-                  <c:v>28</c:v>
+                  <c:v>35</c:v>
                 </c:pt>
               </c:numCache>
             </c:numRef>
@@ -1026,7 +1026,7 @@
           <a:p>
             <a:r>
               <a:rPr lang="en-US" dirty="0"/>
-              <a:t>No top-down hand-waving — this is clinics times revenue per clinic. Twenty clinics and $200K in year one, a million in year two, $3.8 million, $11.5 million, $28 million by year five — which is still only about 3% of the serviceable market. Gross margin holds above 70% blended. Year two onward assumes the $10 million seed closes on the 20-clinic proof point.</a:t>
+              <a:t>No top-down hand-waving — this is clinics times revenue per clinic. Twenty clinics and $200K in year one, a million in year two, $3.8 million, $11.5 million, $35 million by year five — which is still only about 3% of the serviceable market. Gross margin holds above 70% blended. Year two onward assumes the $10 million seed closes on the 20-clinic proof point.</a:t>
             </a:r>
             <a:endParaRPr lang="en-US" dirty="0"/>
           </a:p>
@@ -1114,7 +1114,7 @@
           <a:p>
             <a:r>
               <a:rPr lang="en-US" dirty="0"/>
-              <a:t>Exits in this category are proven, recent and large: R1 RCM went private at $8.9 billion in 2024, athenahealth at $17 billion, Jane App holds a $1.8 billion private mark, and Tebra just raised $250 million. Recent RCM deals price around 4.3 times revenue. The base case — five times on $28 million of ARR — is a $140-million-plus outcome, 15 to 25x this round. The upside case is the AI-native successor to R1, and that is not a $140M company.</a:t>
+              <a:t>Exits in this category are proven, recent and large: R1 RCM went private at $8.9 billion in 2024, athenahealth at $17 billion, Jane App holds a $1.8 billion private mark, and Tebra just raised $250 million. Recent RCM deals price around 4.3 times revenue. The base case — five times on $35 million of ARR — is a $175-million-plus outcome, 18 to 30x this round. The upside case is the AI-native successor to R1, and that is not a $175M company.</a:t>
             </a:r>
             <a:endParaRPr lang="en-US" dirty="0"/>
           </a:p>
@@ -4297,7 +4297,7 @@
                 <a:ea typeface="Trebuchet MS" pitchFamily="34" charset="-122"/>
                 <a:cs typeface="Trebuchet MS" pitchFamily="34" charset="-120"/>
               </a:rPr>
-              <a:t>Bottoms-up to $28M ARR in five years.</a:t>
+              <a:t>Bottoms-up to $35M ARR in five years.</a:t>
             </a:r>
             <a:endParaRPr lang="en-US" sz="2400" dirty="0"/>
           </a:p>
@@ -5215,7 +5215,7 @@
                 <a:ea typeface="Calibri" pitchFamily="34" charset="-122"/>
                 <a:cs typeface="Calibri" pitchFamily="34" charset="-120"/>
               </a:rPr>
-              <a:t>Base: ~5× on $28M ARR is a $140M+ outcome → 15–25× on this round.  Upside: category-leader comp (Jane App) → 50×+.</a:t>
+              <a:t>Base: ~5× on $35M ARR is a $175M+ outcome → 18–30× on this round.  Upside: category-leader comp (Jane App) → 50×+.</a:t>
             </a:r>
             <a:endParaRPr lang="en-US" sz="1150" dirty="0"/>
           </a:p>

</xml_diff>

<commit_message>
Standardize ARPU to ~$12K: SAM ~$1.2B, SOM $35M now reconciles
- Market slide + notes: SAM $480M -> ~$1.2B (100K practices x ~$12K/yr)
- Pitch package TAM (~$2.0B), SAM (~$1.2B) aligned to platform pricing
- SOM $35M now ~3% of SAM by revenue as well as by clinic count

Co-Authored-By: Claude Opus 4.8 <noreply@anthropic.com>
</commit_message>
<xml_diff>
--- a/docs/fundraising/pitch-deck-2026-06-11-softbank-necx.pptx
+++ b/docs/fundraising/pitch-deck-2026-06-11-softbank-necx.pptx
@@ -1818,7 +1818,7 @@
           <a:p>
             <a:r>
               <a:rPr lang="en-US" dirty="0"/>
-              <a:t>Sizing is layered and conservative. The macro: US RCM is $65 billion headed to $196 billion by 2035. Our serviceable layer: 100,000 independent practices at $4,800 a year is $480 million. The wedge entry: 5 to 10 thousand practices in their first year, every year — the moment the financial pain is acute. And the honest trend, said before you ask: independent share fell from 60 to 42 percent — which is exactly why today's independents are the conviction cohort, with DPC growing double digits.</a:t>
+              <a:t>Sizing is layered and conservative. The macro: US RCM is $65 billion headed to $196 billion by 2035. Our serviceable layer: 100,000 independent practices at about $12K a year is roughly $1.2 billion. The wedge entry: 5 to 10 thousand practices in their first year, every year — the moment the financial pain is acute. And the honest trend, said before you ask: independent share fell from 60 to 42 percent — which is exactly why today's independents are the conviction cohort, with DPC growing double digits.</a:t>
             </a:r>
             <a:endParaRPr lang="en-US" dirty="0"/>
           </a:p>
@@ -11447,7 +11447,7 @@
                 <a:ea typeface="Trebuchet MS" pitchFamily="34" charset="-122"/>
                 <a:cs typeface="Trebuchet MS" pitchFamily="34" charset="-120"/>
               </a:rPr>
-              <a:t>$480M</a:t>
+              <a:t>~$1.2B</a:t>
             </a:r>
             <a:endParaRPr lang="en-US" sz="1900" dirty="0"/>
           </a:p>
@@ -11486,7 +11486,7 @@
                 <a:ea typeface="Calibri" pitchFamily="34" charset="-122"/>
                 <a:cs typeface="Calibri" pitchFamily="34" charset="-120"/>
               </a:rPr>
-              <a:t>serviceable market: 100,000 independent practices × $4,800 / yr</a:t>
+              <a:t>serviceable market: 100,000 independent practices × ~$12K / yr</a:t>
             </a:r>
             <a:endParaRPr lang="en-US" sz="1100" dirty="0"/>
           </a:p>

</xml_diff>

<commit_message>
Apply investor-panel feedback to deck + add 1-page exec summary
- Slide 3: one-sentence headline (story-led "what we do")
- Slide 11: retitled to $35M floor + credible path to $100M (land-and-expand)
- New: docs/fundraising/executive-summary-2026-06-22.md (one-pager, standard template)

Co-Authored-By: Claude Opus 4.8 <noreply@anthropic.com>
</commit_message>
<xml_diff>
--- a/docs/fundraising/pitch-deck-2026-06-11-softbank-necx.pptx
+++ b/docs/fundraising/pitch-deck-2026-06-11-softbank-necx.pptx
@@ -1026,7 +1026,7 @@
           <a:p>
             <a:r>
               <a:rPr lang="en-US" dirty="0"/>
-              <a:t>No top-down hand-waving — this is clinics times revenue per clinic. Twenty clinics and $200K in year one, a million in year two, $3.8 million, $11.5 million, $35 million by year five — which is still only about 3% of the serviceable market. Gross margin holds above 70% blended. Year two onward assumes the $10 million seed closes on the 20-clinic proof point.</a:t>
+              <a:t>No top-down hand-waving — this is clinics times revenue per clinic. Twenty clinics and $200K in year one, then $1M, $3.8M, $11.5M, $35M by year five — still only about 3% of the serviceable market. That $35M is the conservative floor. The scale story they want: the path to $100M is land-and-expand — same clinics, rising take as we add RCM and payments, lifting ARPU from $12K toward $25K. $100M is about 4% of our $1.2B SAM and under 1% of the $65B RCM market. We are not market-constrained; we are execution-constrained.</a:t>
             </a:r>
             <a:endParaRPr lang="en-US" dirty="0"/>
           </a:p>
@@ -4289,7 +4289,7 @@
               <a:buNone/>
             </a:pPr>
             <a:r>
-              <a:rPr lang="en-US" sz="2400" b="1" dirty="0">
+              <a:rPr lang="en-US" sz="2100" b="1" dirty="0">
                 <a:solidFill>
                   <a:srgbClr val="FFFFFF"/>
                 </a:solidFill>
@@ -4297,9 +4297,9 @@
                 <a:ea typeface="Trebuchet MS" pitchFamily="34" charset="-122"/>
                 <a:cs typeface="Trebuchet MS" pitchFamily="34" charset="-120"/>
               </a:rPr>
-              <a:t>Bottoms-up to $35M ARR in five years.</a:t>
-            </a:r>
-            <a:endParaRPr lang="en-US" sz="2400" dirty="0"/>
+              <a:t>A $35M floor — and a credible path to $100M.</a:t>
+            </a:r>
+            <a:endParaRPr lang="en-US" sz="2100" dirty="0"/>
           </a:p>
         </p:txBody>
       </p:sp>
@@ -4487,6 +4487,59 @@
       <p:sp>
         <p:nvSpPr>
           <p:cNvPr id="8" name="Text 5"/>
+          <p:cNvSpPr/>
+          <p:nvPr/>
+        </p:nvSpPr>
+        <p:spPr>
+          <a:xfrm>
+            <a:off x="457200" y="4434840"/>
+            <a:ext cx="7955280" cy="566928"/>
+          </a:xfrm>
+          <a:prstGeom prst="rect">
+            <a:avLst/>
+          </a:prstGeom>
+          <a:noFill/>
+          <a:ln/>
+        </p:spPr>
+        <p:txBody>
+          <a:bodyPr wrap="square" lIns="0" tIns="0" rIns="0" bIns="0" rtlCol="0" anchor="t"/>
+          <a:lstStyle/>
+          <a:p>
+            <a:pPr indent="0" marL="0">
+              <a:buNone/>
+            </a:pPr>
+            <a:r>
+              <a:rPr lang="en-US" sz="1050" b="1" i="1" dirty="0">
+                <a:solidFill>
+                  <a:srgbClr val="2DD4BF"/>
+                </a:solidFill>
+                <a:latin typeface="Calibri" pitchFamily="34" charset="0"/>
+                <a:ea typeface="Calibri" pitchFamily="34" charset="-122"/>
+                <a:cs typeface="Calibri" pitchFamily="34" charset="-120"/>
+              </a:rPr>
+              <a:t>PATH TO $100M:  </a:t>
+            </a:r>
+            <a:pPr indent="0" marL="0">
+              <a:buNone/>
+            </a:pPr>
+            <a:r>
+              <a:rPr lang="en-US" sz="1050" i="1" dirty="0">
+                <a:solidFill>
+                  <a:srgbClr val="5EEAD4"/>
+                </a:solidFill>
+                <a:latin typeface="Calibri" pitchFamily="34" charset="0"/>
+                <a:ea typeface="Calibri" pitchFamily="34" charset="-122"/>
+                <a:cs typeface="Calibri" pitchFamily="34" charset="-120"/>
+              </a:rPr>
+              <a:t>land the clinic, then expand take — add RCM + payments to lift ARPU ~$12K → ~$25K. $100M ≈ 4% of our $1.2B SAM, &lt;1% of the $65B RCM market.</a:t>
+            </a:r>
+            <a:endParaRPr lang="en-US" sz="1050" dirty="0"/>
+          </a:p>
+        </p:txBody>
+      </p:sp>
+      <p:sp>
+        <p:nvSpPr>
+          <p:cNvPr id="9" name="Text 6"/>
           <p:cNvSpPr/>
           <p:nvPr/>
         </p:nvSpPr>
@@ -10067,7 +10120,7 @@
               <a:buNone/>
             </a:pPr>
             <a:r>
-              <a:rPr lang="en-US" sz="2200" b="1" dirty="0">
+              <a:rPr lang="en-US" sz="1800" b="1" dirty="0">
                 <a:solidFill>
                   <a:srgbClr val="FFFFFF"/>
                 </a:solidFill>
@@ -10075,9 +10128,9 @@
                 <a:ea typeface="Trebuchet MS" pitchFamily="34" charset="-122"/>
                 <a:cs typeface="Trebuchet MS" pitchFamily="34" charset="-120"/>
               </a:rPr>
-              <a:t>A wedge earning revenue today. A platform that owns the layer.</a:t>
-            </a:r>
-            <a:endParaRPr lang="en-US" sz="2200" dirty="0"/>
+              <a:t>We help newly independent doctors find the money they're losing in year one.</a:t>
+            </a:r>
+            <a:endParaRPr lang="en-US" sz="1800" dirty="0"/>
           </a:p>
         </p:txBody>
       </p:sp>

</xml_diff>